<commit_message>
Team slide and founder lines from the founder's CV and LinkedIn
Co-authored-by: Bryan Kwandou <bryan.kwandou05@gmail.com>

Co-authored-by: Bryan Kwandou <nayrbryangaming01@gmail.com>
</commit_message>
<xml_diff>
--- a/pitch/commish-pitch-editable.pptx
+++ b/pitch/commish-pitch-editable.pptx
@@ -600,7 +600,7 @@
           <a:p>
             <a:r>
               <a:rPr lang="en-US" dirty="0"/>
-              <a:t>I'm Bryan Kwandou. I built Commish on my own: the program, the app in four languages and the tests, across five days of public commits. I also publish open-source tools for decks, writing and video editing. The code is the proof, and all of it is on GitHub. The next step is real campaigns.</a:t>
+              <a:t>I'm Bryan Kwandou. I've sold my own art on Objkt since 2022 and on Drip since 2024, and I earn through Shutterstock and Upwork, so every payout I get runs on someone else's schedule. I study informatics in Makassar and lead the Superteam campus club there. I built Commish's program, app and tests myself.</a:t>
             </a:r>
             <a:endParaRPr lang="en-US" dirty="0"/>
           </a:p>
@@ -2285,7 +2285,7 @@
                 <a:ea typeface="Arial" pitchFamily="34" charset="-122"/>
                 <a:cs typeface="Arial" pitchFamily="34" charset="-120"/>
               </a:rPr>
-              <a:t>One founder built the program, app and tests in five days.</a:t>
+              <a:t>Built by a creator who gets paid on other people's schedules.</a:t>
             </a:r>
             <a:endParaRPr lang="en-US" sz="2800" dirty="0"/>
           </a:p>
@@ -2488,7 +2488,7 @@
                 <a:ea typeface="Arial" pitchFamily="34" charset="-122"/>
                 <a:cs typeface="Arial" pitchFamily="34" charset="-120"/>
               </a:rPr>
-              <a:t>Founder</a:t>
+              <a:t>Founder · Makassar, Indonesia</a:t>
             </a:r>
             <a:endParaRPr lang="en-US" sz="1300" dirty="0"/>
           </a:p>
@@ -2527,7 +2527,7 @@
                 <a:ea typeface="Consolas" pitchFamily="34" charset="-122"/>
                 <a:cs typeface="Consolas" pitchFamily="34" charset="-120"/>
               </a:rPr>
-              <a:t>BUILT</a:t>
+              <a:t>CREATOR</a:t>
             </a:r>
             <a:endParaRPr lang="en-US" sz="1000" dirty="0"/>
           </a:p>
@@ -2566,7 +2566,7 @@
                 <a:ea typeface="Arial" pitchFamily="34" charset="-122"/>
                 <a:cs typeface="Arial" pitchFamily="34" charset="-120"/>
               </a:rPr>
-              <a:t>The Pinocchio program, the four-language app and 26 tests</a:t>
+              <a:t>NFT art on Objkt since 2022 and Drip since 2024; Shutterstock, Upwork</a:t>
             </a:r>
             <a:endParaRPr lang="en-US" sz="1400" dirty="0"/>
           </a:p>
@@ -2605,7 +2605,7 @@
                 <a:ea typeface="Consolas" pitchFamily="34" charset="-122"/>
                 <a:cs typeface="Consolas" pitchFamily="34" charset="-120"/>
               </a:rPr>
-              <a:t>SHIPS</a:t>
+              <a:t>BUILDER</a:t>
             </a:r>
             <a:endParaRPr lang="en-US" sz="1000" dirty="0"/>
           </a:p>
@@ -2644,7 +2644,7 @@
                 <a:ea typeface="Arial" pitchFamily="34" charset="-122"/>
                 <a:cs typeface="Arial" pitchFamily="34" charset="-120"/>
               </a:rPr>
-              <a:t>Open-source tools for builders: Plinth, Lugas, Splicecraft</a:t>
+              <a:t>Informatics, Atma Jaya Makassar; Superteam campus lead</a:t>
             </a:r>
             <a:endParaRPr lang="en-US" sz="1400" dirty="0"/>
           </a:p>
@@ -2683,7 +2683,7 @@
                 <a:ea typeface="Consolas" pitchFamily="34" charset="-122"/>
                 <a:cs typeface="Consolas" pitchFamily="34" charset="-120"/>
               </a:rPr>
-              <a:t>CODE</a:t>
+              <a:t>SHIPPED</a:t>
             </a:r>
             <a:endParaRPr lang="en-US" sz="1000" dirty="0"/>
           </a:p>
@@ -2722,7 +2722,7 @@
                 <a:ea typeface="Arial" pitchFamily="34" charset="-122"/>
                 <a:cs typeface="Arial" pitchFamily="34" charset="-120"/>
               </a:rPr>
-              <a:t>github.com/bryankwandou/commish, every commit public</a:t>
+              <a:t>The program, the app and 26 tests: github.com/bryankwandou/commish</a:t>
             </a:r>
             <a:endParaRPr lang="en-US" sz="1400" dirty="0"/>
           </a:p>

</xml_diff>

<commit_message>
Answer why brands opt in: provable payout reliability
- New deck slide 5 with a sourced survey figure (S8, secondary)
- Landing page brand points lead with proving you pay, in four locales

Co-Authored-By: Claude Opus 5.5 <noreply@anthropic.com>
Claude-Session: https://claude.ai/code/session_01MRVtPx7m8bURgCFAk82H2f
</commit_message>
<xml_diff>
--- a/pitch/commish-pitch-editable.pptx
+++ b/pitch/commish-pitch-editable.pptx
@@ -16,9 +16,10 @@
     <p:sldId id="264" r:id="rId10"/>
     <p:sldId id="265" r:id="rId11"/>
     <p:sldId id="266" r:id="rId12"/>
+    <p:sldId id="267" r:id="rId13"/>
   </p:sldIdLst>
   <p:notesMasterIdLst>
-    <p:notesMasterId r:id="rId13"/>
+    <p:notesMasterId r:id="rId14"/>
   </p:notesMasterIdLst>
   <p:sldSz cx="9144000" cy="5143500"/>
   <p:notesSz cx="5143500" cy="9144000"/>
@@ -600,7 +601,7 @@
           <a:p>
             <a:r>
               <a:rPr lang="en-US" dirty="0"/>
-              <a:t>I'm Bryan Kwandou. I've sold my own art on Objkt since 2022 and on Drip since 2024, and I earn through Shutterstock and Upwork, so every payout I get runs on someone else's schedule. I study informatics in Makassar and lead the Superteam campus club there. I built Commish's program, app and tests myself.</a:t>
+              <a:t>US affiliate spend alone is forecast at about fourteen billion dollars this year [S3], and Goldman Sachs counts fifty million creators worldwide [S4]. Our own plan is a one percent fee on each payout. If one percent of US affiliate spend settled through Commish, that's about 1.4 million dollars a year. Dollar stablecoins have had a US law behind them since July 2025 [S5].</a:t>
             </a:r>
             <a:endParaRPr lang="en-US" dirty="0"/>
           </a:p>
@@ -688,7 +689,7 @@
           <a:p>
             <a:r>
               <a:rPr lang="en-US" dirty="0"/>
-              <a:t>Here's the plan. The program and the app are done. Next is the mainnet deploy and a first live campaign, then ten pilots with Solana apps that already pay creators and hold USDC. After that, an audit and a Shopify integration through order webhooks. If you run an affiliate program, try it at getcommish.vercel.app.</a:t>
+              <a:t>I'm Bryan Kwandou. I've sold my own art on Objkt since 2022 and on Drip since 2024, and I earn through Shutterstock and Upwork, so every payout I get runs on someone else's schedule. I study informatics in Makassar and lead the Superteam campus club there. I built Commish's program, app and tests myself.</a:t>
             </a:r>
             <a:endParaRPr lang="en-US" dirty="0"/>
           </a:p>
@@ -712,6 +713,94 @@
             <a:fld id="{F7021451-1387-4CA6-816F-3879F97B5CBC}" type="slidenum">
               <a:rPr lang="en-US"/>
               <a:t>11</a:t>
+            </a:fld>
+            <a:endParaRPr lang="en-US"/>
+          </a:p>
+        </p:txBody>
+      </p:sp>
+    </p:spTree>
+    <p:extLst>
+      <p:ext uri="{BB962C8B-B14F-4D97-AF65-F5344CB8AC3E}">
+        <p14:creationId xmlns:p14="http://schemas.microsoft.com/office/powerpoint/2010/main" val="1024086991"/>
+      </p:ext>
+    </p:extLst>
+  </p:cSld>
+  <p:clrMapOvr>
+    <a:masterClrMapping/>
+  </p:clrMapOvr>
+</p:notes>
+</file>
+
+<file path=ppt/notesSlides/notesSlide12.xml><?xml version="1.0" encoding="utf-8"?>
+<p:notes xmlns:a="http://schemas.openxmlformats.org/drawingml/2006/main" xmlns:r="http://schemas.openxmlformats.org/officeDocument/2006/relationships" xmlns:p="http://schemas.openxmlformats.org/presentationml/2006/main">
+  <p:cSld>
+    <p:spTree>
+      <p:nvGrpSpPr>
+        <p:cNvPr id="1" name=""/>
+        <p:cNvGrpSpPr/>
+        <p:nvPr/>
+      </p:nvGrpSpPr>
+      <p:grpSpPr>
+        <a:xfrm>
+          <a:off x="0" y="0"/>
+          <a:ext cx="0" cy="0"/>
+          <a:chOff x="0" y="0"/>
+          <a:chExt cx="0" cy="0"/>
+        </a:xfrm>
+      </p:grpSpPr>
+      <p:sp>
+        <p:nvSpPr>
+          <p:cNvPr id="2" name="Slide Image Placeholder 1"/>
+          <p:cNvSpPr>
+            <a:spLocks noGrp="1" noRot="1" noChangeAspect="1"/>
+          </p:cNvSpPr>
+          <p:nvPr>
+            <p:ph type="sldImg"/>
+          </p:nvPr>
+        </p:nvSpPr>
+        <p:spPr/>
+      </p:sp>
+      <p:sp>
+        <p:nvSpPr>
+          <p:cNvPr id="3" name="Notes Placeholder 2"/>
+          <p:cNvSpPr>
+            <a:spLocks noGrp="1"/>
+          </p:cNvSpPr>
+          <p:nvPr>
+            <p:ph type="body" idx="1"/>
+          </p:nvPr>
+        </p:nvSpPr>
+        <p:spPr/>
+        <p:txBody>
+          <a:bodyPr/>
+          <a:lstStyle/>
+          <a:p>
+            <a:r>
+              <a:rPr lang="en-US" dirty="0"/>
+              <a:t>Here's the plan. The program and the app are done. Next is the mainnet deploy and a first live campaign, then ten pilots with Solana apps that already pay creators and hold USDC. After that, an audit and a Shopify integration through order webhooks. If you run an affiliate program, try it at getcommish.vercel.app.</a:t>
+            </a:r>
+            <a:endParaRPr lang="en-US" dirty="0"/>
+          </a:p>
+        </p:txBody>
+      </p:sp>
+      <p:sp>
+        <p:nvSpPr>
+          <p:cNvPr id="4" name="Slide Number Placeholder 3"/>
+          <p:cNvSpPr>
+            <a:spLocks noGrp="1"/>
+          </p:cNvSpPr>
+          <p:nvPr>
+            <p:ph type="sldNum" sz="quarter" idx="10"/>
+          </p:nvPr>
+        </p:nvSpPr>
+        <p:spPr/>
+        <p:txBody>
+          <a:bodyPr/>
+          <a:lstStyle/>
+          <a:p>
+            <a:fld id="{F7021451-1387-4CA6-816F-3879F97B5CBC}" type="slidenum">
+              <a:rPr lang="en-US"/>
+              <a:t>12</a:t>
             </a:fld>
             <a:endParaRPr lang="en-US"/>
           </a:p>
@@ -1040,7 +1129,7 @@
           <a:p>
             <a:r>
               <a:rPr lang="en-US" dirty="0"/>
-              <a:t>Three steps. The attestor records the sale, and the program computes the cut, not the caller. The commission sits through the refund window. Then anyone can release it, the creator or a bot, and the money can only land in the payee's own USDC account. If this website went offline tomorrow, creators could still collect.</a:t>
+              <a:t>Why would a brand lock its own money? Because affiliates choose programs by whether they get paid. In a PerformanceIN survey of 3,200 affiliates in crypto, forex and gambling, 73 percent said payout reliability was their main reason to switch programs [S8]. A Commish campaign shows its reserved and paid totals on-chain, so a brand can prove it pays before a creator signs up.</a:t>
             </a:r>
             <a:endParaRPr lang="en-US" dirty="0"/>
           </a:p>
@@ -1128,7 +1217,7 @@
           <a:p>
             <a:r>
               <a:rPr lang="en-US" dirty="0"/>
-              <a:t>A pending commission is money owed on a known date, so it can be sold. Here the creator sells a twenty-five dollar commission for 24.25 and is paid right away. The buyer becomes the payee, collects the full amount at release, and takes over the refund risk. It all settles in one transaction.</a:t>
+              <a:t>Three steps. The attestor records the sale, and the program computes the cut, not the caller. The commission sits through the refund window. Then anyone can release it, the creator or a bot, and the money can only land in the payee's own USDC account. If this website went offline tomorrow, creators could still collect.</a:t>
             </a:r>
             <a:endParaRPr lang="en-US" dirty="0"/>
           </a:p>
@@ -1216,7 +1305,7 @@
           <a:p>
             <a:r>
               <a:rPr lang="en-US" dirty="0"/>
-              <a:t>All of it is one Solana program written with Pinocchio: 9,296 bytes, small enough that deploying it to mainnet costs under 0.05 SOL. Each rule here is checked on-chain, and the test suite has an attack for each one that has to fail. A transaction's base fee is 5,000 lamports per signature [S6], cheap enough to run for every order.</a:t>
+              <a:t>A pending commission is money owed on a known date, so it can be sold. Here the creator sells a twenty-five dollar commission for 24.25 and is paid right away. The buyer becomes the payee, collects the full amount at release, and takes over the refund risk. It all settles in one transaction.</a:t>
             </a:r>
             <a:endParaRPr lang="en-US" dirty="0"/>
           </a:p>
@@ -1304,7 +1393,7 @@
           <a:p>
             <a:r>
               <a:rPr lang="en-US" dirty="0"/>
-              <a:t>We checked before building. Colosseum's project search turns up eight earlier Solana affiliate or referral projects, and none placed [S7]. Three of them promised instant payouts, which no brand accepts while one online order in five comes back. Commish keeps the refund window brands already use, and guarantees the money inside it.</a:t>
+              <a:t>All of it is one Solana program written with Pinocchio: 9,296 bytes, small enough that deploying it to mainnet costs under 0.05 SOL. Each rule here is checked on-chain, and the test suite has an attack for each one that has to fail. A transaction's base fee is 5,000 lamports per signature [S6], cheap enough to run for every order.</a:t>
             </a:r>
             <a:endParaRPr lang="en-US" dirty="0"/>
           </a:p>
@@ -1392,7 +1481,7 @@
           <a:p>
             <a:r>
               <a:rPr lang="en-US" dirty="0"/>
-              <a:t>US affiliate spend alone is forecast at about fourteen billion dollars this year [S3], and Goldman Sachs counts fifty million creators worldwide [S4]. Our own plan is a one percent fee on each payout. If one percent of US affiliate spend settled through Commish, that's about 1.4 million dollars a year. Dollar stablecoins have had a US law behind them since July 2025 [S5].</a:t>
+              <a:t>We checked before building. Colosseum's project search turns up eight earlier Solana affiliate or referral projects, and none placed [S7]. Three of them promised instant payouts, which no brand accepts while one online order in five comes back. Commish keeps the refund window brands already use, and guarantees the money inside it.</a:t>
             </a:r>
             <a:endParaRPr lang="en-US" dirty="0"/>
           </a:p>
@@ -2244,7 +2333,7 @@
                 <a:ea typeface="Arial" pitchFamily="34" charset="-122"/>
                 <a:cs typeface="Arial" pitchFamily="34" charset="-120"/>
               </a:rPr>
-              <a:t>TEAM</a:t>
+              <a:t>MARKET</a:t>
             </a:r>
             <a:endParaRPr lang="en-US" sz="1000" dirty="0"/>
           </a:p>
@@ -2285,7 +2374,7 @@
                 <a:ea typeface="Arial" pitchFamily="34" charset="-122"/>
                 <a:cs typeface="Arial" pitchFamily="34" charset="-120"/>
               </a:rPr>
-              <a:t>Built by a creator who gets paid on other people's schedules.</a:t>
+              <a:t>US brands will spend $13.81 billion on affiliate marketing in 2026.</a:t>
             </a:r>
             <a:endParaRPr lang="en-US" sz="2800" dirty="0"/>
           </a:p>
@@ -2354,17 +2443,490 @@
       </p:sp>
       <p:sp>
         <p:nvSpPr>
-          <p:cNvPr id="6" name="Shape 4"/>
-          <p:cNvSpPr/>
-          <p:nvPr/>
-        </p:nvSpPr>
-        <p:spPr>
-          <a:xfrm>
-            <a:off x="548640" y="1874520"/>
-            <a:ext cx="1005840" cy="1005840"/>
-          </a:xfrm>
-          <a:prstGeom prst="ellipse">
-            <a:avLst/>
+          <p:cNvPr id="6" name="Text 4"/>
+          <p:cNvSpPr/>
+          <p:nvPr/>
+        </p:nvSpPr>
+        <p:spPr>
+          <a:xfrm>
+            <a:off x="548640" y="1691640"/>
+            <a:ext cx="5486400" cy="1371600"/>
+          </a:xfrm>
+          <a:prstGeom prst="rect">
+            <a:avLst/>
+          </a:prstGeom>
+          <a:noFill/>
+          <a:ln/>
+        </p:spPr>
+        <p:txBody>
+          <a:bodyPr wrap="square" lIns="0" tIns="0" rIns="0" bIns="0" rtlCol="0" anchor="ctr"/>
+          <a:lstStyle/>
+          <a:p>
+            <a:pPr indent="0" marL="0">
+              <a:buNone/>
+            </a:pPr>
+            <a:r>
+              <a:rPr lang="en-US" sz="8400" b="1" dirty="0">
+                <a:solidFill>
+                  <a:srgbClr val="3DDC97"/>
+                </a:solidFill>
+                <a:latin typeface="Arial" pitchFamily="34" charset="0"/>
+                <a:ea typeface="Arial" pitchFamily="34" charset="-122"/>
+                <a:cs typeface="Arial" pitchFamily="34" charset="-120"/>
+              </a:rPr>
+              <a:t>$13.81B</a:t>
+            </a:r>
+            <a:endParaRPr lang="en-US" sz="8400" dirty="0"/>
+          </a:p>
+        </p:txBody>
+      </p:sp>
+      <p:sp>
+        <p:nvSpPr>
+          <p:cNvPr id="7" name="Shape 5"/>
+          <p:cNvSpPr/>
+          <p:nvPr/>
+        </p:nvSpPr>
+        <p:spPr>
+          <a:xfrm>
+            <a:off x="548640" y="3337560"/>
+            <a:ext cx="1645920" cy="868680"/>
+          </a:xfrm>
+          <a:prstGeom prst="roundRect">
+            <a:avLst>
+              <a:gd name="adj" fmla="val 10526"/>
+            </a:avLst>
+          </a:prstGeom>
+          <a:solidFill>
+            <a:srgbClr val="141417"/>
+          </a:solidFill>
+          <a:ln w="12700">
+            <a:solidFill>
+              <a:srgbClr val="27272A"/>
+            </a:solidFill>
+            <a:prstDash val="solid"/>
+          </a:ln>
+        </p:spPr>
+      </p:sp>
+      <p:sp>
+        <p:nvSpPr>
+          <p:cNvPr id="8" name="Text 6"/>
+          <p:cNvSpPr/>
+          <p:nvPr/>
+        </p:nvSpPr>
+        <p:spPr>
+          <a:xfrm>
+            <a:off x="685800" y="3410712"/>
+            <a:ext cx="1417320" cy="411480"/>
+          </a:xfrm>
+          <a:prstGeom prst="rect">
+            <a:avLst/>
+          </a:prstGeom>
+          <a:noFill/>
+          <a:ln/>
+        </p:spPr>
+        <p:txBody>
+          <a:bodyPr wrap="square" lIns="0" tIns="0" rIns="0" bIns="0" rtlCol="0" anchor="ctr"/>
+          <a:lstStyle/>
+          <a:p>
+            <a:pPr indent="0" marL="0">
+              <a:buNone/>
+            </a:pPr>
+            <a:r>
+              <a:rPr lang="en-US" sz="2000" b="1" dirty="0">
+                <a:solidFill>
+                  <a:srgbClr val="F4F4F5"/>
+                </a:solidFill>
+                <a:latin typeface="Arial" pitchFamily="34" charset="0"/>
+                <a:ea typeface="Arial" pitchFamily="34" charset="-122"/>
+                <a:cs typeface="Arial" pitchFamily="34" charset="-120"/>
+              </a:rPr>
+              <a:t>$13.81B</a:t>
+            </a:r>
+            <a:endParaRPr lang="en-US" sz="2000" dirty="0"/>
+          </a:p>
+        </p:txBody>
+      </p:sp>
+      <p:sp>
+        <p:nvSpPr>
+          <p:cNvPr id="9" name="Text 7"/>
+          <p:cNvSpPr/>
+          <p:nvPr/>
+        </p:nvSpPr>
+        <p:spPr>
+          <a:xfrm>
+            <a:off x="685800" y="3822192"/>
+            <a:ext cx="1463040" cy="274320"/>
+          </a:xfrm>
+          <a:prstGeom prst="rect">
+            <a:avLst/>
+          </a:prstGeom>
+          <a:noFill/>
+          <a:ln/>
+        </p:spPr>
+        <p:txBody>
+          <a:bodyPr wrap="square" lIns="0" tIns="0" rIns="0" bIns="0" rtlCol="0" anchor="ctr"/>
+          <a:lstStyle/>
+          <a:p>
+            <a:pPr indent="0" marL="0">
+              <a:buNone/>
+            </a:pPr>
+            <a:r>
+              <a:rPr lang="en-US" sz="1000" dirty="0">
+                <a:solidFill>
+                  <a:srgbClr val="A1A1AA"/>
+                </a:solidFill>
+                <a:latin typeface="Arial" pitchFamily="34" charset="0"/>
+                <a:ea typeface="Arial" pitchFamily="34" charset="-122"/>
+                <a:cs typeface="Arial" pitchFamily="34" charset="-120"/>
+              </a:rPr>
+              <a:t>US affiliate spend</a:t>
+            </a:r>
+            <a:endParaRPr lang="en-US" sz="1000" dirty="0"/>
+          </a:p>
+        </p:txBody>
+      </p:sp>
+      <p:sp>
+        <p:nvSpPr>
+          <p:cNvPr id="10" name="Text 8"/>
+          <p:cNvSpPr/>
+          <p:nvPr/>
+        </p:nvSpPr>
+        <p:spPr>
+          <a:xfrm>
+            <a:off x="2194560" y="3566160"/>
+            <a:ext cx="365760" cy="411480"/>
+          </a:xfrm>
+          <a:prstGeom prst="rect">
+            <a:avLst/>
+          </a:prstGeom>
+          <a:noFill/>
+          <a:ln/>
+        </p:spPr>
+        <p:txBody>
+          <a:bodyPr wrap="square" lIns="0" tIns="0" rIns="0" bIns="0" rtlCol="0" anchor="ctr"/>
+          <a:lstStyle/>
+          <a:p>
+            <a:pPr algn="ctr" indent="0" marL="0">
+              <a:buNone/>
+            </a:pPr>
+            <a:r>
+              <a:rPr lang="en-US" sz="1800" dirty="0">
+                <a:solidFill>
+                  <a:srgbClr val="A1A1AA"/>
+                </a:solidFill>
+                <a:latin typeface="Arial" pitchFamily="34" charset="0"/>
+                <a:ea typeface="Arial" pitchFamily="34" charset="-122"/>
+                <a:cs typeface="Arial" pitchFamily="34" charset="-120"/>
+              </a:rPr>
+              <a:t>×</a:t>
+            </a:r>
+            <a:endParaRPr lang="en-US" sz="1800" dirty="0"/>
+          </a:p>
+        </p:txBody>
+      </p:sp>
+      <p:sp>
+        <p:nvSpPr>
+          <p:cNvPr id="11" name="Shape 9"/>
+          <p:cNvSpPr/>
+          <p:nvPr/>
+        </p:nvSpPr>
+        <p:spPr>
+          <a:xfrm>
+            <a:off x="2560320" y="3337560"/>
+            <a:ext cx="1645920" cy="868680"/>
+          </a:xfrm>
+          <a:prstGeom prst="roundRect">
+            <a:avLst>
+              <a:gd name="adj" fmla="val 10526"/>
+            </a:avLst>
+          </a:prstGeom>
+          <a:solidFill>
+            <a:srgbClr val="141417"/>
+          </a:solidFill>
+          <a:ln w="12700">
+            <a:solidFill>
+              <a:srgbClr val="27272A"/>
+            </a:solidFill>
+            <a:prstDash val="solid"/>
+          </a:ln>
+        </p:spPr>
+      </p:sp>
+      <p:sp>
+        <p:nvSpPr>
+          <p:cNvPr id="12" name="Text 10"/>
+          <p:cNvSpPr/>
+          <p:nvPr/>
+        </p:nvSpPr>
+        <p:spPr>
+          <a:xfrm>
+            <a:off x="2697480" y="3410712"/>
+            <a:ext cx="1417320" cy="411480"/>
+          </a:xfrm>
+          <a:prstGeom prst="rect">
+            <a:avLst/>
+          </a:prstGeom>
+          <a:noFill/>
+          <a:ln/>
+        </p:spPr>
+        <p:txBody>
+          <a:bodyPr wrap="square" lIns="0" tIns="0" rIns="0" bIns="0" rtlCol="0" anchor="ctr"/>
+          <a:lstStyle/>
+          <a:p>
+            <a:pPr indent="0" marL="0">
+              <a:buNone/>
+            </a:pPr>
+            <a:r>
+              <a:rPr lang="en-US" sz="2000" b="1" dirty="0">
+                <a:solidFill>
+                  <a:srgbClr val="F4F4F5"/>
+                </a:solidFill>
+                <a:latin typeface="Arial" pitchFamily="34" charset="0"/>
+                <a:ea typeface="Arial" pitchFamily="34" charset="-122"/>
+                <a:cs typeface="Arial" pitchFamily="34" charset="-120"/>
+              </a:rPr>
+              <a:t>1%</a:t>
+            </a:r>
+            <a:endParaRPr lang="en-US" sz="2000" dirty="0"/>
+          </a:p>
+        </p:txBody>
+      </p:sp>
+      <p:sp>
+        <p:nvSpPr>
+          <p:cNvPr id="13" name="Text 11"/>
+          <p:cNvSpPr/>
+          <p:nvPr/>
+        </p:nvSpPr>
+        <p:spPr>
+          <a:xfrm>
+            <a:off x="2697480" y="3822192"/>
+            <a:ext cx="1463040" cy="274320"/>
+          </a:xfrm>
+          <a:prstGeom prst="rect">
+            <a:avLst/>
+          </a:prstGeom>
+          <a:noFill/>
+          <a:ln/>
+        </p:spPr>
+        <p:txBody>
+          <a:bodyPr wrap="square" lIns="0" tIns="0" rIns="0" bIns="0" rtlCol="0" anchor="ctr"/>
+          <a:lstStyle/>
+          <a:p>
+            <a:pPr indent="0" marL="0">
+              <a:buNone/>
+            </a:pPr>
+            <a:r>
+              <a:rPr lang="en-US" sz="1000" dirty="0">
+                <a:solidFill>
+                  <a:srgbClr val="A1A1AA"/>
+                </a:solidFill>
+                <a:latin typeface="Arial" pitchFamily="34" charset="0"/>
+                <a:ea typeface="Arial" pitchFamily="34" charset="-122"/>
+                <a:cs typeface="Arial" pitchFamily="34" charset="-120"/>
+              </a:rPr>
+              <a:t>settled on Commish</a:t>
+            </a:r>
+            <a:endParaRPr lang="en-US" sz="1000" dirty="0"/>
+          </a:p>
+        </p:txBody>
+      </p:sp>
+      <p:sp>
+        <p:nvSpPr>
+          <p:cNvPr id="14" name="Text 12"/>
+          <p:cNvSpPr/>
+          <p:nvPr/>
+        </p:nvSpPr>
+        <p:spPr>
+          <a:xfrm>
+            <a:off x="4206240" y="3566160"/>
+            <a:ext cx="365760" cy="411480"/>
+          </a:xfrm>
+          <a:prstGeom prst="rect">
+            <a:avLst/>
+          </a:prstGeom>
+          <a:noFill/>
+          <a:ln/>
+        </p:spPr>
+        <p:txBody>
+          <a:bodyPr wrap="square" lIns="0" tIns="0" rIns="0" bIns="0" rtlCol="0" anchor="ctr"/>
+          <a:lstStyle/>
+          <a:p>
+            <a:pPr algn="ctr" indent="0" marL="0">
+              <a:buNone/>
+            </a:pPr>
+            <a:r>
+              <a:rPr lang="en-US" sz="1800" dirty="0">
+                <a:solidFill>
+                  <a:srgbClr val="A1A1AA"/>
+                </a:solidFill>
+                <a:latin typeface="Arial" pitchFamily="34" charset="0"/>
+                <a:ea typeface="Arial" pitchFamily="34" charset="-122"/>
+                <a:cs typeface="Arial" pitchFamily="34" charset="-120"/>
+              </a:rPr>
+              <a:t>×</a:t>
+            </a:r>
+            <a:endParaRPr lang="en-US" sz="1800" dirty="0"/>
+          </a:p>
+        </p:txBody>
+      </p:sp>
+      <p:sp>
+        <p:nvSpPr>
+          <p:cNvPr id="15" name="Shape 13"/>
+          <p:cNvSpPr/>
+          <p:nvPr/>
+        </p:nvSpPr>
+        <p:spPr>
+          <a:xfrm>
+            <a:off x="4572000" y="3337560"/>
+            <a:ext cx="1645920" cy="868680"/>
+          </a:xfrm>
+          <a:prstGeom prst="roundRect">
+            <a:avLst>
+              <a:gd name="adj" fmla="val 10526"/>
+            </a:avLst>
+          </a:prstGeom>
+          <a:solidFill>
+            <a:srgbClr val="141417"/>
+          </a:solidFill>
+          <a:ln w="12700">
+            <a:solidFill>
+              <a:srgbClr val="27272A"/>
+            </a:solidFill>
+            <a:prstDash val="solid"/>
+          </a:ln>
+        </p:spPr>
+      </p:sp>
+      <p:sp>
+        <p:nvSpPr>
+          <p:cNvPr id="16" name="Text 14"/>
+          <p:cNvSpPr/>
+          <p:nvPr/>
+        </p:nvSpPr>
+        <p:spPr>
+          <a:xfrm>
+            <a:off x="4709160" y="3410712"/>
+            <a:ext cx="1417320" cy="411480"/>
+          </a:xfrm>
+          <a:prstGeom prst="rect">
+            <a:avLst/>
+          </a:prstGeom>
+          <a:noFill/>
+          <a:ln/>
+        </p:spPr>
+        <p:txBody>
+          <a:bodyPr wrap="square" lIns="0" tIns="0" rIns="0" bIns="0" rtlCol="0" anchor="ctr"/>
+          <a:lstStyle/>
+          <a:p>
+            <a:pPr indent="0" marL="0">
+              <a:buNone/>
+            </a:pPr>
+            <a:r>
+              <a:rPr lang="en-US" sz="2000" b="1" dirty="0">
+                <a:solidFill>
+                  <a:srgbClr val="F4F4F5"/>
+                </a:solidFill>
+                <a:latin typeface="Arial" pitchFamily="34" charset="0"/>
+                <a:ea typeface="Arial" pitchFamily="34" charset="-122"/>
+                <a:cs typeface="Arial" pitchFamily="34" charset="-120"/>
+              </a:rPr>
+              <a:t>1%</a:t>
+            </a:r>
+            <a:endParaRPr lang="en-US" sz="2000" dirty="0"/>
+          </a:p>
+        </p:txBody>
+      </p:sp>
+      <p:sp>
+        <p:nvSpPr>
+          <p:cNvPr id="17" name="Text 15"/>
+          <p:cNvSpPr/>
+          <p:nvPr/>
+        </p:nvSpPr>
+        <p:spPr>
+          <a:xfrm>
+            <a:off x="4709160" y="3822192"/>
+            <a:ext cx="1463040" cy="274320"/>
+          </a:xfrm>
+          <a:prstGeom prst="rect">
+            <a:avLst/>
+          </a:prstGeom>
+          <a:noFill/>
+          <a:ln/>
+        </p:spPr>
+        <p:txBody>
+          <a:bodyPr wrap="square" lIns="0" tIns="0" rIns="0" bIns="0" rtlCol="0" anchor="ctr"/>
+          <a:lstStyle/>
+          <a:p>
+            <a:pPr indent="0" marL="0">
+              <a:buNone/>
+            </a:pPr>
+            <a:r>
+              <a:rPr lang="en-US" sz="1000" dirty="0">
+                <a:solidFill>
+                  <a:srgbClr val="A1A1AA"/>
+                </a:solidFill>
+                <a:latin typeface="Arial" pitchFamily="34" charset="0"/>
+                <a:ea typeface="Arial" pitchFamily="34" charset="-122"/>
+                <a:cs typeface="Arial" pitchFamily="34" charset="-120"/>
+              </a:rPr>
+              <a:t>fee on each payout</a:t>
+            </a:r>
+            <a:endParaRPr lang="en-US" sz="1000" dirty="0"/>
+          </a:p>
+        </p:txBody>
+      </p:sp>
+      <p:sp>
+        <p:nvSpPr>
+          <p:cNvPr id="18" name="Text 16"/>
+          <p:cNvSpPr/>
+          <p:nvPr/>
+        </p:nvSpPr>
+        <p:spPr>
+          <a:xfrm>
+            <a:off x="6217920" y="3566160"/>
+            <a:ext cx="365760" cy="411480"/>
+          </a:xfrm>
+          <a:prstGeom prst="rect">
+            <a:avLst/>
+          </a:prstGeom>
+          <a:noFill/>
+          <a:ln/>
+        </p:spPr>
+        <p:txBody>
+          <a:bodyPr wrap="square" lIns="0" tIns="0" rIns="0" bIns="0" rtlCol="0" anchor="ctr"/>
+          <a:lstStyle/>
+          <a:p>
+            <a:pPr algn="ctr" indent="0" marL="0">
+              <a:buNone/>
+            </a:pPr>
+            <a:r>
+              <a:rPr lang="en-US" sz="1800" dirty="0">
+                <a:solidFill>
+                  <a:srgbClr val="A1A1AA"/>
+                </a:solidFill>
+                <a:latin typeface="Arial" pitchFamily="34" charset="0"/>
+                <a:ea typeface="Arial" pitchFamily="34" charset="-122"/>
+                <a:cs typeface="Arial" pitchFamily="34" charset="-120"/>
+              </a:rPr>
+              <a:t>=</a:t>
+            </a:r>
+            <a:endParaRPr lang="en-US" sz="1800" dirty="0"/>
+          </a:p>
+        </p:txBody>
+      </p:sp>
+      <p:sp>
+        <p:nvSpPr>
+          <p:cNvPr id="19" name="Shape 17"/>
+          <p:cNvSpPr/>
+          <p:nvPr/>
+        </p:nvSpPr>
+        <p:spPr>
+          <a:xfrm>
+            <a:off x="6583680" y="3337560"/>
+            <a:ext cx="1645920" cy="868680"/>
+          </a:xfrm>
+          <a:prstGeom prst="roundRect">
+            <a:avLst>
+              <a:gd name="adj" fmla="val 10526"/>
+            </a:avLst>
           </a:prstGeom>
           <a:solidFill>
             <a:srgbClr val="141417"/>
@@ -2379,14 +2941,14 @@
       </p:sp>
       <p:sp>
         <p:nvSpPr>
-          <p:cNvPr id="7" name="Text 5"/>
-          <p:cNvSpPr/>
-          <p:nvPr/>
-        </p:nvSpPr>
-        <p:spPr>
-          <a:xfrm>
-            <a:off x="548640" y="1874520"/>
-            <a:ext cx="1005840" cy="1005840"/>
+          <p:cNvPr id="20" name="Text 18"/>
+          <p:cNvSpPr/>
+          <p:nvPr/>
+        </p:nvSpPr>
+        <p:spPr>
+          <a:xfrm>
+            <a:off x="6720840" y="3410712"/>
+            <a:ext cx="1417320" cy="411480"/>
           </a:xfrm>
           <a:prstGeom prst="rect">
             <a:avLst/>
@@ -2398,11 +2960,11 @@
           <a:bodyPr wrap="square" lIns="0" tIns="0" rIns="0" bIns="0" rtlCol="0" anchor="ctr"/>
           <a:lstStyle/>
           <a:p>
-            <a:pPr algn="ctr" indent="0" marL="0">
-              <a:buNone/>
-            </a:pPr>
-            <a:r>
-              <a:rPr lang="en-US" sz="2600" b="1" dirty="0">
+            <a:pPr indent="0" marL="0">
+              <a:buNone/>
+            </a:pPr>
+            <a:r>
+              <a:rPr lang="en-US" sz="2000" b="1" dirty="0">
                 <a:solidFill>
                   <a:srgbClr val="3DDC97"/>
                 </a:solidFill>
@@ -2410,22 +2972,22 @@
                 <a:ea typeface="Arial" pitchFamily="34" charset="-122"/>
                 <a:cs typeface="Arial" pitchFamily="34" charset="-120"/>
               </a:rPr>
-              <a:t>BK</a:t>
-            </a:r>
-            <a:endParaRPr lang="en-US" sz="2600" dirty="0"/>
-          </a:p>
-        </p:txBody>
-      </p:sp>
-      <p:sp>
-        <p:nvSpPr>
-          <p:cNvPr id="8" name="Text 6"/>
-          <p:cNvSpPr/>
-          <p:nvPr/>
-        </p:nvSpPr>
-        <p:spPr>
-          <a:xfrm>
-            <a:off x="1783080" y="2011680"/>
-            <a:ext cx="4572000" cy="411480"/>
+              <a:t>$1.38M</a:t>
+            </a:r>
+            <a:endParaRPr lang="en-US" sz="2000" dirty="0"/>
+          </a:p>
+        </p:txBody>
+      </p:sp>
+      <p:sp>
+        <p:nvSpPr>
+          <p:cNvPr id="21" name="Text 19"/>
+          <p:cNvSpPr/>
+          <p:nvPr/>
+        </p:nvSpPr>
+        <p:spPr>
+          <a:xfrm>
+            <a:off x="6720840" y="3822192"/>
+            <a:ext cx="1463040" cy="274320"/>
           </a:xfrm>
           <a:prstGeom prst="rect">
             <a:avLst/>
@@ -2441,30 +3003,30 @@
               <a:buNone/>
             </a:pPr>
             <a:r>
-              <a:rPr lang="en-US" sz="2000" b="1" dirty="0">
-                <a:solidFill>
-                  <a:srgbClr val="F4F4F5"/>
+              <a:rPr lang="en-US" sz="1000" dirty="0">
+                <a:solidFill>
+                  <a:srgbClr val="A1A1AA"/>
                 </a:solidFill>
                 <a:latin typeface="Arial" pitchFamily="34" charset="0"/>
                 <a:ea typeface="Arial" pitchFamily="34" charset="-122"/>
                 <a:cs typeface="Arial" pitchFamily="34" charset="-120"/>
               </a:rPr>
-              <a:t>Bryan Kwandou</a:t>
-            </a:r>
-            <a:endParaRPr lang="en-US" sz="2000" dirty="0"/>
-          </a:p>
-        </p:txBody>
-      </p:sp>
-      <p:sp>
-        <p:nvSpPr>
-          <p:cNvPr id="9" name="Text 7"/>
-          <p:cNvSpPr/>
-          <p:nvPr/>
-        </p:nvSpPr>
-        <p:spPr>
-          <a:xfrm>
-            <a:off x="1783080" y="2423160"/>
-            <a:ext cx="4572000" cy="320040"/>
+              <a:t>a year</a:t>
+            </a:r>
+            <a:endParaRPr lang="en-US" sz="1000" dirty="0"/>
+          </a:p>
+        </p:txBody>
+      </p:sp>
+      <p:sp>
+        <p:nvSpPr>
+          <p:cNvPr id="22" name="Text 20"/>
+          <p:cNvSpPr/>
+          <p:nvPr/>
+        </p:nvSpPr>
+        <p:spPr>
+          <a:xfrm>
+            <a:off x="548640" y="4681728"/>
+            <a:ext cx="7589520" cy="274320"/>
           </a:xfrm>
           <a:prstGeom prst="rect">
             <a:avLst/>
@@ -2480,251 +3042,17 @@
               <a:buNone/>
             </a:pPr>
             <a:r>
-              <a:rPr lang="en-US" sz="1300" dirty="0">
-                <a:solidFill>
-                  <a:srgbClr val="A1A1AA"/>
+              <a:rPr lang="en-US" sz="900" dirty="0">
+                <a:solidFill>
+                  <a:srgbClr val="71717A"/>
                 </a:solidFill>
                 <a:latin typeface="Arial" pitchFamily="34" charset="0"/>
                 <a:ea typeface="Arial" pitchFamily="34" charset="-122"/>
                 <a:cs typeface="Arial" pitchFamily="34" charset="-120"/>
               </a:rPr>
-              <a:t>Founder · Makassar, Indonesia</a:t>
-            </a:r>
-            <a:endParaRPr lang="en-US" sz="1300" dirty="0"/>
-          </a:p>
-        </p:txBody>
-      </p:sp>
-      <p:sp>
-        <p:nvSpPr>
-          <p:cNvPr id="10" name="Text 8"/>
-          <p:cNvSpPr/>
-          <p:nvPr/>
-        </p:nvSpPr>
-        <p:spPr>
-          <a:xfrm>
-            <a:off x="548640" y="3154680"/>
-            <a:ext cx="914400" cy="329184"/>
-          </a:xfrm>
-          <a:prstGeom prst="rect">
-            <a:avLst/>
-          </a:prstGeom>
-          <a:noFill/>
-          <a:ln/>
-        </p:spPr>
-        <p:txBody>
-          <a:bodyPr wrap="square" lIns="0" tIns="0" rIns="0" bIns="0" rtlCol="0" anchor="ctr"/>
-          <a:lstStyle/>
-          <a:p>
-            <a:pPr indent="0" marL="0">
-              <a:buNone/>
-            </a:pPr>
-            <a:r>
-              <a:rPr lang="en-US" sz="1000" b="1" dirty="0">
-                <a:solidFill>
-                  <a:srgbClr val="3DDC97"/>
-                </a:solidFill>
-                <a:latin typeface="Consolas" pitchFamily="34" charset="0"/>
-                <a:ea typeface="Consolas" pitchFamily="34" charset="-122"/>
-                <a:cs typeface="Consolas" pitchFamily="34" charset="-120"/>
-              </a:rPr>
-              <a:t>CREATOR</a:t>
-            </a:r>
-            <a:endParaRPr lang="en-US" sz="1000" dirty="0"/>
-          </a:p>
-        </p:txBody>
-      </p:sp>
-      <p:sp>
-        <p:nvSpPr>
-          <p:cNvPr id="11" name="Text 9"/>
-          <p:cNvSpPr/>
-          <p:nvPr/>
-        </p:nvSpPr>
-        <p:spPr>
-          <a:xfrm>
-            <a:off x="1783080" y="3154680"/>
-            <a:ext cx="6675120" cy="329184"/>
-          </a:xfrm>
-          <a:prstGeom prst="rect">
-            <a:avLst/>
-          </a:prstGeom>
-          <a:noFill/>
-          <a:ln/>
-        </p:spPr>
-        <p:txBody>
-          <a:bodyPr wrap="square" lIns="0" tIns="0" rIns="0" bIns="0" rtlCol="0" anchor="ctr"/>
-          <a:lstStyle/>
-          <a:p>
-            <a:pPr indent="0" marL="0">
-              <a:buNone/>
-            </a:pPr>
-            <a:r>
-              <a:rPr lang="en-US" sz="1400" dirty="0">
-                <a:solidFill>
-                  <a:srgbClr val="F4F4F5"/>
-                </a:solidFill>
-                <a:latin typeface="Arial" pitchFamily="34" charset="0"/>
-                <a:ea typeface="Arial" pitchFamily="34" charset="-122"/>
-                <a:cs typeface="Arial" pitchFamily="34" charset="-120"/>
-              </a:rPr>
-              <a:t>NFT art on Objkt since 2022 and Drip since 2024; Shutterstock, Upwork</a:t>
-            </a:r>
-            <a:endParaRPr lang="en-US" sz="1400" dirty="0"/>
-          </a:p>
-        </p:txBody>
-      </p:sp>
-      <p:sp>
-        <p:nvSpPr>
-          <p:cNvPr id="12" name="Text 10"/>
-          <p:cNvSpPr/>
-          <p:nvPr/>
-        </p:nvSpPr>
-        <p:spPr>
-          <a:xfrm>
-            <a:off x="548640" y="3611880"/>
-            <a:ext cx="914400" cy="329184"/>
-          </a:xfrm>
-          <a:prstGeom prst="rect">
-            <a:avLst/>
-          </a:prstGeom>
-          <a:noFill/>
-          <a:ln/>
-        </p:spPr>
-        <p:txBody>
-          <a:bodyPr wrap="square" lIns="0" tIns="0" rIns="0" bIns="0" rtlCol="0" anchor="ctr"/>
-          <a:lstStyle/>
-          <a:p>
-            <a:pPr indent="0" marL="0">
-              <a:buNone/>
-            </a:pPr>
-            <a:r>
-              <a:rPr lang="en-US" sz="1000" b="1" dirty="0">
-                <a:solidFill>
-                  <a:srgbClr val="3DDC97"/>
-                </a:solidFill>
-                <a:latin typeface="Consolas" pitchFamily="34" charset="0"/>
-                <a:ea typeface="Consolas" pitchFamily="34" charset="-122"/>
-                <a:cs typeface="Consolas" pitchFamily="34" charset="-120"/>
-              </a:rPr>
-              <a:t>BUILDER</a:t>
-            </a:r>
-            <a:endParaRPr lang="en-US" sz="1000" dirty="0"/>
-          </a:p>
-        </p:txBody>
-      </p:sp>
-      <p:sp>
-        <p:nvSpPr>
-          <p:cNvPr id="13" name="Text 11"/>
-          <p:cNvSpPr/>
-          <p:nvPr/>
-        </p:nvSpPr>
-        <p:spPr>
-          <a:xfrm>
-            <a:off x="1783080" y="3611880"/>
-            <a:ext cx="6675120" cy="329184"/>
-          </a:xfrm>
-          <a:prstGeom prst="rect">
-            <a:avLst/>
-          </a:prstGeom>
-          <a:noFill/>
-          <a:ln/>
-        </p:spPr>
-        <p:txBody>
-          <a:bodyPr wrap="square" lIns="0" tIns="0" rIns="0" bIns="0" rtlCol="0" anchor="ctr"/>
-          <a:lstStyle/>
-          <a:p>
-            <a:pPr indent="0" marL="0">
-              <a:buNone/>
-            </a:pPr>
-            <a:r>
-              <a:rPr lang="en-US" sz="1400" dirty="0">
-                <a:solidFill>
-                  <a:srgbClr val="F4F4F5"/>
-                </a:solidFill>
-                <a:latin typeface="Arial" pitchFamily="34" charset="0"/>
-                <a:ea typeface="Arial" pitchFamily="34" charset="-122"/>
-                <a:cs typeface="Arial" pitchFamily="34" charset="-120"/>
-              </a:rPr>
-              <a:t>Informatics, Atma Jaya Makassar; Superteam campus lead</a:t>
-            </a:r>
-            <a:endParaRPr lang="en-US" sz="1400" dirty="0"/>
-          </a:p>
-        </p:txBody>
-      </p:sp>
-      <p:sp>
-        <p:nvSpPr>
-          <p:cNvPr id="14" name="Text 12"/>
-          <p:cNvSpPr/>
-          <p:nvPr/>
-        </p:nvSpPr>
-        <p:spPr>
-          <a:xfrm>
-            <a:off x="548640" y="4069080"/>
-            <a:ext cx="914400" cy="329184"/>
-          </a:xfrm>
-          <a:prstGeom prst="rect">
-            <a:avLst/>
-          </a:prstGeom>
-          <a:noFill/>
-          <a:ln/>
-        </p:spPr>
-        <p:txBody>
-          <a:bodyPr wrap="square" lIns="0" tIns="0" rIns="0" bIns="0" rtlCol="0" anchor="ctr"/>
-          <a:lstStyle/>
-          <a:p>
-            <a:pPr indent="0" marL="0">
-              <a:buNone/>
-            </a:pPr>
-            <a:r>
-              <a:rPr lang="en-US" sz="1000" b="1" dirty="0">
-                <a:solidFill>
-                  <a:srgbClr val="3DDC97"/>
-                </a:solidFill>
-                <a:latin typeface="Consolas" pitchFamily="34" charset="0"/>
-                <a:ea typeface="Consolas" pitchFamily="34" charset="-122"/>
-                <a:cs typeface="Consolas" pitchFamily="34" charset="-120"/>
-              </a:rPr>
-              <a:t>SHIPPED</a:t>
-            </a:r>
-            <a:endParaRPr lang="en-US" sz="1000" dirty="0"/>
-          </a:p>
-        </p:txBody>
-      </p:sp>
-      <p:sp>
-        <p:nvSpPr>
-          <p:cNvPr id="15" name="Text 13"/>
-          <p:cNvSpPr/>
-          <p:nvPr/>
-        </p:nvSpPr>
-        <p:spPr>
-          <a:xfrm>
-            <a:off x="1783080" y="4069080"/>
-            <a:ext cx="6675120" cy="329184"/>
-          </a:xfrm>
-          <a:prstGeom prst="rect">
-            <a:avLst/>
-          </a:prstGeom>
-          <a:noFill/>
-          <a:ln/>
-        </p:spPr>
-        <p:txBody>
-          <a:bodyPr wrap="square" lIns="0" tIns="0" rIns="0" bIns="0" rtlCol="0" anchor="ctr"/>
-          <a:lstStyle/>
-          <a:p>
-            <a:pPr indent="0" marL="0">
-              <a:buNone/>
-            </a:pPr>
-            <a:r>
-              <a:rPr lang="en-US" sz="1400" dirty="0">
-                <a:solidFill>
-                  <a:srgbClr val="F4F4F5"/>
-                </a:solidFill>
-                <a:latin typeface="Arial" pitchFamily="34" charset="0"/>
-                <a:ea typeface="Arial" pitchFamily="34" charset="-122"/>
-                <a:cs typeface="Arial" pitchFamily="34" charset="-120"/>
-              </a:rPr>
-              <a:t>The program, the app and 26 tests: github.com/bryankwandou/commish</a:t>
-            </a:r>
-            <a:endParaRPr lang="en-US" sz="1400" dirty="0"/>
+              <a:t>Source: eMarketer forecast via Post Affiliate Pro [S3]. Share and fee are team plan, not outside data.</a:t>
+            </a:r>
+            <a:endParaRPr lang="en-US" sz="900" dirty="0"/>
           </a:p>
         </p:txBody>
       </p:sp>
@@ -2793,7 +3121,7 @@
                 <a:ea typeface="Arial" pitchFamily="34" charset="-122"/>
                 <a:cs typeface="Arial" pitchFamily="34" charset="-120"/>
               </a:rPr>
-              <a:t>NEXT</a:t>
+              <a:t>TEAM</a:t>
             </a:r>
             <a:endParaRPr lang="en-US" sz="1000" dirty="0"/>
           </a:p>
@@ -2834,7 +3162,7 @@
                 <a:ea typeface="Arial" pitchFamily="34" charset="-122"/>
                 <a:cs typeface="Arial" pitchFamily="34" charset="-120"/>
               </a:rPr>
-              <a:t>Next: ten Solana brands run their creator payouts through Commish.</a:t>
+              <a:t>Built by a creator who gets paid on other people's schedules.</a:t>
             </a:r>
             <a:endParaRPr lang="en-US" sz="2800" dirty="0"/>
           </a:p>
@@ -2896,6 +3224,555 @@
                 <a:cs typeface="Consolas" pitchFamily="34" charset="-120"/>
               </a:rPr>
               <a:t>11</a:t>
+            </a:r>
+            <a:endParaRPr lang="en-US" sz="1000" dirty="0"/>
+          </a:p>
+        </p:txBody>
+      </p:sp>
+      <p:sp>
+        <p:nvSpPr>
+          <p:cNvPr id="6" name="Shape 4"/>
+          <p:cNvSpPr/>
+          <p:nvPr/>
+        </p:nvSpPr>
+        <p:spPr>
+          <a:xfrm>
+            <a:off x="548640" y="1874520"/>
+            <a:ext cx="1005840" cy="1005840"/>
+          </a:xfrm>
+          <a:prstGeom prst="ellipse">
+            <a:avLst/>
+          </a:prstGeom>
+          <a:solidFill>
+            <a:srgbClr val="141417"/>
+          </a:solidFill>
+          <a:ln w="19050">
+            <a:solidFill>
+              <a:srgbClr val="3DDC97"/>
+            </a:solidFill>
+            <a:prstDash val="solid"/>
+          </a:ln>
+        </p:spPr>
+      </p:sp>
+      <p:sp>
+        <p:nvSpPr>
+          <p:cNvPr id="7" name="Text 5"/>
+          <p:cNvSpPr/>
+          <p:nvPr/>
+        </p:nvSpPr>
+        <p:spPr>
+          <a:xfrm>
+            <a:off x="548640" y="1874520"/>
+            <a:ext cx="1005840" cy="1005840"/>
+          </a:xfrm>
+          <a:prstGeom prst="rect">
+            <a:avLst/>
+          </a:prstGeom>
+          <a:noFill/>
+          <a:ln/>
+        </p:spPr>
+        <p:txBody>
+          <a:bodyPr wrap="square" lIns="0" tIns="0" rIns="0" bIns="0" rtlCol="0" anchor="ctr"/>
+          <a:lstStyle/>
+          <a:p>
+            <a:pPr algn="ctr" indent="0" marL="0">
+              <a:buNone/>
+            </a:pPr>
+            <a:r>
+              <a:rPr lang="en-US" sz="2600" b="1" dirty="0">
+                <a:solidFill>
+                  <a:srgbClr val="3DDC97"/>
+                </a:solidFill>
+                <a:latin typeface="Arial" pitchFamily="34" charset="0"/>
+                <a:ea typeface="Arial" pitchFamily="34" charset="-122"/>
+                <a:cs typeface="Arial" pitchFamily="34" charset="-120"/>
+              </a:rPr>
+              <a:t>BK</a:t>
+            </a:r>
+            <a:endParaRPr lang="en-US" sz="2600" dirty="0"/>
+          </a:p>
+        </p:txBody>
+      </p:sp>
+      <p:sp>
+        <p:nvSpPr>
+          <p:cNvPr id="8" name="Text 6"/>
+          <p:cNvSpPr/>
+          <p:nvPr/>
+        </p:nvSpPr>
+        <p:spPr>
+          <a:xfrm>
+            <a:off x="1783080" y="2011680"/>
+            <a:ext cx="4572000" cy="411480"/>
+          </a:xfrm>
+          <a:prstGeom prst="rect">
+            <a:avLst/>
+          </a:prstGeom>
+          <a:noFill/>
+          <a:ln/>
+        </p:spPr>
+        <p:txBody>
+          <a:bodyPr wrap="square" lIns="0" tIns="0" rIns="0" bIns="0" rtlCol="0" anchor="ctr"/>
+          <a:lstStyle/>
+          <a:p>
+            <a:pPr indent="0" marL="0">
+              <a:buNone/>
+            </a:pPr>
+            <a:r>
+              <a:rPr lang="en-US" sz="2000" b="1" dirty="0">
+                <a:solidFill>
+                  <a:srgbClr val="F4F4F5"/>
+                </a:solidFill>
+                <a:latin typeface="Arial" pitchFamily="34" charset="0"/>
+                <a:ea typeface="Arial" pitchFamily="34" charset="-122"/>
+                <a:cs typeface="Arial" pitchFamily="34" charset="-120"/>
+              </a:rPr>
+              <a:t>Bryan Kwandou</a:t>
+            </a:r>
+            <a:endParaRPr lang="en-US" sz="2000" dirty="0"/>
+          </a:p>
+        </p:txBody>
+      </p:sp>
+      <p:sp>
+        <p:nvSpPr>
+          <p:cNvPr id="9" name="Text 7"/>
+          <p:cNvSpPr/>
+          <p:nvPr/>
+        </p:nvSpPr>
+        <p:spPr>
+          <a:xfrm>
+            <a:off x="1783080" y="2423160"/>
+            <a:ext cx="4572000" cy="320040"/>
+          </a:xfrm>
+          <a:prstGeom prst="rect">
+            <a:avLst/>
+          </a:prstGeom>
+          <a:noFill/>
+          <a:ln/>
+        </p:spPr>
+        <p:txBody>
+          <a:bodyPr wrap="square" lIns="0" tIns="0" rIns="0" bIns="0" rtlCol="0" anchor="ctr"/>
+          <a:lstStyle/>
+          <a:p>
+            <a:pPr indent="0" marL="0">
+              <a:buNone/>
+            </a:pPr>
+            <a:r>
+              <a:rPr lang="en-US" sz="1300" dirty="0">
+                <a:solidFill>
+                  <a:srgbClr val="A1A1AA"/>
+                </a:solidFill>
+                <a:latin typeface="Arial" pitchFamily="34" charset="0"/>
+                <a:ea typeface="Arial" pitchFamily="34" charset="-122"/>
+                <a:cs typeface="Arial" pitchFamily="34" charset="-120"/>
+              </a:rPr>
+              <a:t>Founder · Makassar, Indonesia</a:t>
+            </a:r>
+            <a:endParaRPr lang="en-US" sz="1300" dirty="0"/>
+          </a:p>
+        </p:txBody>
+      </p:sp>
+      <p:sp>
+        <p:nvSpPr>
+          <p:cNvPr id="10" name="Text 8"/>
+          <p:cNvSpPr/>
+          <p:nvPr/>
+        </p:nvSpPr>
+        <p:spPr>
+          <a:xfrm>
+            <a:off x="548640" y="3154680"/>
+            <a:ext cx="914400" cy="329184"/>
+          </a:xfrm>
+          <a:prstGeom prst="rect">
+            <a:avLst/>
+          </a:prstGeom>
+          <a:noFill/>
+          <a:ln/>
+        </p:spPr>
+        <p:txBody>
+          <a:bodyPr wrap="square" lIns="0" tIns="0" rIns="0" bIns="0" rtlCol="0" anchor="ctr"/>
+          <a:lstStyle/>
+          <a:p>
+            <a:pPr indent="0" marL="0">
+              <a:buNone/>
+            </a:pPr>
+            <a:r>
+              <a:rPr lang="en-US" sz="1000" b="1" dirty="0">
+                <a:solidFill>
+                  <a:srgbClr val="3DDC97"/>
+                </a:solidFill>
+                <a:latin typeface="Consolas" pitchFamily="34" charset="0"/>
+                <a:ea typeface="Consolas" pitchFamily="34" charset="-122"/>
+                <a:cs typeface="Consolas" pitchFamily="34" charset="-120"/>
+              </a:rPr>
+              <a:t>CREATOR</a:t>
+            </a:r>
+            <a:endParaRPr lang="en-US" sz="1000" dirty="0"/>
+          </a:p>
+        </p:txBody>
+      </p:sp>
+      <p:sp>
+        <p:nvSpPr>
+          <p:cNvPr id="11" name="Text 9"/>
+          <p:cNvSpPr/>
+          <p:nvPr/>
+        </p:nvSpPr>
+        <p:spPr>
+          <a:xfrm>
+            <a:off x="1783080" y="3154680"/>
+            <a:ext cx="6675120" cy="329184"/>
+          </a:xfrm>
+          <a:prstGeom prst="rect">
+            <a:avLst/>
+          </a:prstGeom>
+          <a:noFill/>
+          <a:ln/>
+        </p:spPr>
+        <p:txBody>
+          <a:bodyPr wrap="square" lIns="0" tIns="0" rIns="0" bIns="0" rtlCol="0" anchor="ctr"/>
+          <a:lstStyle/>
+          <a:p>
+            <a:pPr indent="0" marL="0">
+              <a:buNone/>
+            </a:pPr>
+            <a:r>
+              <a:rPr lang="en-US" sz="1400" dirty="0">
+                <a:solidFill>
+                  <a:srgbClr val="F4F4F5"/>
+                </a:solidFill>
+                <a:latin typeface="Arial" pitchFamily="34" charset="0"/>
+                <a:ea typeface="Arial" pitchFamily="34" charset="-122"/>
+                <a:cs typeface="Arial" pitchFamily="34" charset="-120"/>
+              </a:rPr>
+              <a:t>NFT art on Objkt since 2022 and Drip since 2024; Shutterstock, Upwork</a:t>
+            </a:r>
+            <a:endParaRPr lang="en-US" sz="1400" dirty="0"/>
+          </a:p>
+        </p:txBody>
+      </p:sp>
+      <p:sp>
+        <p:nvSpPr>
+          <p:cNvPr id="12" name="Text 10"/>
+          <p:cNvSpPr/>
+          <p:nvPr/>
+        </p:nvSpPr>
+        <p:spPr>
+          <a:xfrm>
+            <a:off x="548640" y="3611880"/>
+            <a:ext cx="914400" cy="329184"/>
+          </a:xfrm>
+          <a:prstGeom prst="rect">
+            <a:avLst/>
+          </a:prstGeom>
+          <a:noFill/>
+          <a:ln/>
+        </p:spPr>
+        <p:txBody>
+          <a:bodyPr wrap="square" lIns="0" tIns="0" rIns="0" bIns="0" rtlCol="0" anchor="ctr"/>
+          <a:lstStyle/>
+          <a:p>
+            <a:pPr indent="0" marL="0">
+              <a:buNone/>
+            </a:pPr>
+            <a:r>
+              <a:rPr lang="en-US" sz="1000" b="1" dirty="0">
+                <a:solidFill>
+                  <a:srgbClr val="3DDC97"/>
+                </a:solidFill>
+                <a:latin typeface="Consolas" pitchFamily="34" charset="0"/>
+                <a:ea typeface="Consolas" pitchFamily="34" charset="-122"/>
+                <a:cs typeface="Consolas" pitchFamily="34" charset="-120"/>
+              </a:rPr>
+              <a:t>BUILDER</a:t>
+            </a:r>
+            <a:endParaRPr lang="en-US" sz="1000" dirty="0"/>
+          </a:p>
+        </p:txBody>
+      </p:sp>
+      <p:sp>
+        <p:nvSpPr>
+          <p:cNvPr id="13" name="Text 11"/>
+          <p:cNvSpPr/>
+          <p:nvPr/>
+        </p:nvSpPr>
+        <p:spPr>
+          <a:xfrm>
+            <a:off x="1783080" y="3611880"/>
+            <a:ext cx="6675120" cy="329184"/>
+          </a:xfrm>
+          <a:prstGeom prst="rect">
+            <a:avLst/>
+          </a:prstGeom>
+          <a:noFill/>
+          <a:ln/>
+        </p:spPr>
+        <p:txBody>
+          <a:bodyPr wrap="square" lIns="0" tIns="0" rIns="0" bIns="0" rtlCol="0" anchor="ctr"/>
+          <a:lstStyle/>
+          <a:p>
+            <a:pPr indent="0" marL="0">
+              <a:buNone/>
+            </a:pPr>
+            <a:r>
+              <a:rPr lang="en-US" sz="1400" dirty="0">
+                <a:solidFill>
+                  <a:srgbClr val="F4F4F5"/>
+                </a:solidFill>
+                <a:latin typeface="Arial" pitchFamily="34" charset="0"/>
+                <a:ea typeface="Arial" pitchFamily="34" charset="-122"/>
+                <a:cs typeface="Arial" pitchFamily="34" charset="-120"/>
+              </a:rPr>
+              <a:t>Informatics, Atma Jaya Makassar; Superteam campus lead</a:t>
+            </a:r>
+            <a:endParaRPr lang="en-US" sz="1400" dirty="0"/>
+          </a:p>
+        </p:txBody>
+      </p:sp>
+      <p:sp>
+        <p:nvSpPr>
+          <p:cNvPr id="14" name="Text 12"/>
+          <p:cNvSpPr/>
+          <p:nvPr/>
+        </p:nvSpPr>
+        <p:spPr>
+          <a:xfrm>
+            <a:off x="548640" y="4069080"/>
+            <a:ext cx="914400" cy="329184"/>
+          </a:xfrm>
+          <a:prstGeom prst="rect">
+            <a:avLst/>
+          </a:prstGeom>
+          <a:noFill/>
+          <a:ln/>
+        </p:spPr>
+        <p:txBody>
+          <a:bodyPr wrap="square" lIns="0" tIns="0" rIns="0" bIns="0" rtlCol="0" anchor="ctr"/>
+          <a:lstStyle/>
+          <a:p>
+            <a:pPr indent="0" marL="0">
+              <a:buNone/>
+            </a:pPr>
+            <a:r>
+              <a:rPr lang="en-US" sz="1000" b="1" dirty="0">
+                <a:solidFill>
+                  <a:srgbClr val="3DDC97"/>
+                </a:solidFill>
+                <a:latin typeface="Consolas" pitchFamily="34" charset="0"/>
+                <a:ea typeface="Consolas" pitchFamily="34" charset="-122"/>
+                <a:cs typeface="Consolas" pitchFamily="34" charset="-120"/>
+              </a:rPr>
+              <a:t>SHIPPED</a:t>
+            </a:r>
+            <a:endParaRPr lang="en-US" sz="1000" dirty="0"/>
+          </a:p>
+        </p:txBody>
+      </p:sp>
+      <p:sp>
+        <p:nvSpPr>
+          <p:cNvPr id="15" name="Text 13"/>
+          <p:cNvSpPr/>
+          <p:nvPr/>
+        </p:nvSpPr>
+        <p:spPr>
+          <a:xfrm>
+            <a:off x="1783080" y="4069080"/>
+            <a:ext cx="6675120" cy="329184"/>
+          </a:xfrm>
+          <a:prstGeom prst="rect">
+            <a:avLst/>
+          </a:prstGeom>
+          <a:noFill/>
+          <a:ln/>
+        </p:spPr>
+        <p:txBody>
+          <a:bodyPr wrap="square" lIns="0" tIns="0" rIns="0" bIns="0" rtlCol="0" anchor="ctr"/>
+          <a:lstStyle/>
+          <a:p>
+            <a:pPr indent="0" marL="0">
+              <a:buNone/>
+            </a:pPr>
+            <a:r>
+              <a:rPr lang="en-US" sz="1400" dirty="0">
+                <a:solidFill>
+                  <a:srgbClr val="F4F4F5"/>
+                </a:solidFill>
+                <a:latin typeface="Arial" pitchFamily="34" charset="0"/>
+                <a:ea typeface="Arial" pitchFamily="34" charset="-122"/>
+                <a:cs typeface="Arial" pitchFamily="34" charset="-120"/>
+              </a:rPr>
+              <a:t>The program, the app and 26 tests: github.com/bryankwandou/commish</a:t>
+            </a:r>
+            <a:endParaRPr lang="en-US" sz="1400" dirty="0"/>
+          </a:p>
+        </p:txBody>
+      </p:sp>
+    </p:spTree>
+  </p:cSld>
+  <p:clrMapOvr>
+    <a:masterClrMapping/>
+  </p:clrMapOvr>
+</p:sld>
+</file>
+
+<file path=ppt/slides/slide12.xml><?xml version="1.0" encoding="utf-8"?>
+<p:sld xmlns:a="http://schemas.openxmlformats.org/drawingml/2006/main" xmlns:r="http://schemas.openxmlformats.org/officeDocument/2006/relationships" xmlns:p="http://schemas.openxmlformats.org/presentationml/2006/main">
+  <p:cSld name="Slide 12">
+    <p:bg>
+      <p:bgPr>
+        <a:solidFill>
+          <a:srgbClr val="0B0B0E"/>
+        </a:solidFill>
+      </p:bgPr>
+    </p:bg>
+    <p:spTree>
+      <p:nvGrpSpPr>
+        <p:cNvPr id="1" name=""/>
+        <p:cNvGrpSpPr/>
+        <p:nvPr/>
+      </p:nvGrpSpPr>
+      <p:grpSpPr>
+        <a:xfrm>
+          <a:off x="0" y="0"/>
+          <a:ext cx="0" cy="0"/>
+          <a:chOff x="0" y="0"/>
+          <a:chExt cx="0" cy="0"/>
+        </a:xfrm>
+      </p:grpSpPr>
+      <p:sp>
+        <p:nvSpPr>
+          <p:cNvPr id="2" name="Text 0"/>
+          <p:cNvSpPr/>
+          <p:nvPr/>
+        </p:nvSpPr>
+        <p:spPr>
+          <a:xfrm>
+            <a:off x="548640" y="384048"/>
+            <a:ext cx="5486400" cy="256032"/>
+          </a:xfrm>
+          <a:prstGeom prst="rect">
+            <a:avLst/>
+          </a:prstGeom>
+          <a:noFill/>
+          <a:ln/>
+        </p:spPr>
+        <p:txBody>
+          <a:bodyPr wrap="square" lIns="0" tIns="0" rIns="0" bIns="0" rtlCol="0" anchor="ctr"/>
+          <a:lstStyle/>
+          <a:p>
+            <a:pPr indent="0" marL="0">
+              <a:buNone/>
+            </a:pPr>
+            <a:r>
+              <a:rPr lang="en-US" sz="1000" b="1" spc="200" kern="0" dirty="0">
+                <a:solidFill>
+                  <a:srgbClr val="A1A1AA"/>
+                </a:solidFill>
+                <a:latin typeface="Arial" pitchFamily="34" charset="0"/>
+                <a:ea typeface="Arial" pitchFamily="34" charset="-122"/>
+                <a:cs typeface="Arial" pitchFamily="34" charset="-120"/>
+              </a:rPr>
+              <a:t>NEXT</a:t>
+            </a:r>
+            <a:endParaRPr lang="en-US" sz="1000" dirty="0"/>
+          </a:p>
+        </p:txBody>
+      </p:sp>
+      <p:sp>
+        <p:nvSpPr>
+          <p:cNvPr id="3" name="Text 1"/>
+          <p:cNvSpPr/>
+          <p:nvPr/>
+        </p:nvSpPr>
+        <p:spPr>
+          <a:xfrm>
+            <a:off x="548640" y="676656"/>
+            <a:ext cx="7498080" cy="914400"/>
+          </a:xfrm>
+          <a:prstGeom prst="rect">
+            <a:avLst/>
+          </a:prstGeom>
+          <a:noFill/>
+          <a:ln/>
+        </p:spPr>
+        <p:txBody>
+          <a:bodyPr wrap="square" lIns="0" tIns="0" rIns="0" bIns="0" rtlCol="0" anchor="t">
+            <a:normAutofit/>
+          </a:bodyPr>
+          <a:lstStyle/>
+          <a:p>
+            <a:pPr indent="0" marL="0">
+              <a:buNone/>
+            </a:pPr>
+            <a:r>
+              <a:rPr lang="en-US" sz="2800" b="1" dirty="0">
+                <a:solidFill>
+                  <a:srgbClr val="F4F4F5"/>
+                </a:solidFill>
+                <a:latin typeface="Arial" pitchFamily="34" charset="0"/>
+                <a:ea typeface="Arial" pitchFamily="34" charset="-122"/>
+                <a:cs typeface="Arial" pitchFamily="34" charset="-120"/>
+              </a:rPr>
+              <a:t>Next: ten Solana brands run their creator payouts through Commish.</a:t>
+            </a:r>
+            <a:endParaRPr lang="en-US" sz="2800" dirty="0"/>
+          </a:p>
+        </p:txBody>
+      </p:sp>
+      <p:sp>
+        <p:nvSpPr>
+          <p:cNvPr id="4" name="Shape 2"/>
+          <p:cNvSpPr/>
+          <p:nvPr/>
+        </p:nvSpPr>
+        <p:spPr>
+          <a:xfrm>
+            <a:off x="8321040" y="4709160"/>
+            <a:ext cx="548640" cy="274320"/>
+          </a:xfrm>
+          <a:prstGeom prst="roundRect">
+            <a:avLst>
+              <a:gd name="adj" fmla="val 50000"/>
+            </a:avLst>
+          </a:prstGeom>
+          <a:solidFill>
+            <a:srgbClr val="27272A"/>
+          </a:solidFill>
+          <a:ln/>
+        </p:spPr>
+      </p:sp>
+      <p:sp>
+        <p:nvSpPr>
+          <p:cNvPr id="5" name="Text 3"/>
+          <p:cNvSpPr/>
+          <p:nvPr/>
+        </p:nvSpPr>
+        <p:spPr>
+          <a:xfrm>
+            <a:off x="8321040" y="4709160"/>
+            <a:ext cx="548640" cy="274320"/>
+          </a:xfrm>
+          <a:prstGeom prst="rect">
+            <a:avLst/>
+          </a:prstGeom>
+          <a:noFill/>
+          <a:ln/>
+        </p:spPr>
+        <p:txBody>
+          <a:bodyPr wrap="square" lIns="0" tIns="0" rIns="0" bIns="0" rtlCol="0" anchor="ctr"/>
+          <a:lstStyle/>
+          <a:p>
+            <a:pPr algn="ctr" indent="0" marL="0">
+              <a:buNone/>
+            </a:pPr>
+            <a:r>
+              <a:rPr lang="en-US" sz="1000" b="1" dirty="0">
+                <a:solidFill>
+                  <a:srgbClr val="A1A1AA"/>
+                </a:solidFill>
+                <a:latin typeface="Consolas" pitchFamily="34" charset="0"/>
+                <a:ea typeface="Consolas" pitchFamily="34" charset="-122"/>
+                <a:cs typeface="Consolas" pitchFamily="34" charset="-120"/>
+              </a:rPr>
+              <a:t>12</a:t>
             </a:r>
             <a:endParaRPr lang="en-US" sz="1000" dirty="0"/>
           </a:p>
@@ -5088,7 +5965,7 @@
                 <a:ea typeface="Arial" pitchFamily="34" charset="-122"/>
                 <a:cs typeface="Arial" pitchFamily="34" charset="-120"/>
               </a:rPr>
-              <a:t>IN USE</a:t>
+              <a:t>WHY BRANDS OPT IN</a:t>
             </a:r>
             <a:endParaRPr lang="en-US" sz="1000" dirty="0"/>
           </a:p>
@@ -5129,7 +6006,7 @@
                 <a:ea typeface="Arial" pitchFamily="34" charset="-122"/>
                 <a:cs typeface="Arial" pitchFamily="34" charset="-120"/>
               </a:rPr>
-              <a:t>Record the sale, hold it through the window, then release.</a:t>
+              <a:t>Affiliates pick programs that pay reliably. Commish makes that provable.</a:t>
             </a:r>
             <a:endParaRPr lang="en-US" sz="2800" dirty="0"/>
           </a:p>
@@ -5198,41 +6075,14 @@
       </p:sp>
       <p:sp>
         <p:nvSpPr>
-          <p:cNvPr id="6" name="Shape 4"/>
-          <p:cNvSpPr/>
-          <p:nvPr/>
-        </p:nvSpPr>
-        <p:spPr>
-          <a:xfrm>
-            <a:off x="548640" y="1965960"/>
-            <a:ext cx="2377440" cy="2057400"/>
-          </a:xfrm>
-          <a:prstGeom prst="roundRect">
-            <a:avLst>
-              <a:gd name="adj" fmla="val 4444"/>
-            </a:avLst>
-          </a:prstGeom>
-          <a:solidFill>
-            <a:srgbClr val="141417"/>
-          </a:solidFill>
-          <a:ln w="12700">
-            <a:solidFill>
-              <a:srgbClr val="27272A"/>
-            </a:solidFill>
-            <a:prstDash val="solid"/>
-          </a:ln>
-        </p:spPr>
-      </p:sp>
-      <p:sp>
-        <p:nvSpPr>
-          <p:cNvPr id="7" name="Text 5"/>
-          <p:cNvSpPr/>
-          <p:nvPr/>
-        </p:nvSpPr>
-        <p:spPr>
-          <a:xfrm>
-            <a:off x="777240" y="2148840"/>
-            <a:ext cx="914400" cy="256032"/>
+          <p:cNvPr id="6" name="Text 4"/>
+          <p:cNvSpPr/>
+          <p:nvPr/>
+        </p:nvSpPr>
+        <p:spPr>
+          <a:xfrm>
+            <a:off x="548640" y="1783080"/>
+            <a:ext cx="4389120" cy="1463040"/>
           </a:xfrm>
           <a:prstGeom prst="rect">
             <a:avLst/>
@@ -5248,69 +6098,30 @@
               <a:buNone/>
             </a:pPr>
             <a:r>
-              <a:rPr lang="en-US" sz="1000" dirty="0">
-                <a:solidFill>
-                  <a:srgbClr val="A1A1AA"/>
-                </a:solidFill>
-                <a:latin typeface="Consolas" pitchFamily="34" charset="0"/>
-                <a:ea typeface="Consolas" pitchFamily="34" charset="-122"/>
-                <a:cs typeface="Consolas" pitchFamily="34" charset="-120"/>
-              </a:rPr>
-              <a:t>01</a:t>
-            </a:r>
-            <a:endParaRPr lang="en-US" sz="1000" dirty="0"/>
-          </a:p>
-        </p:txBody>
-      </p:sp>
-      <p:sp>
-        <p:nvSpPr>
-          <p:cNvPr id="8" name="Text 6"/>
-          <p:cNvSpPr/>
-          <p:nvPr/>
-        </p:nvSpPr>
-        <p:spPr>
-          <a:xfrm>
-            <a:off x="777240" y="2468880"/>
-            <a:ext cx="1920240" cy="384048"/>
-          </a:xfrm>
-          <a:prstGeom prst="rect">
-            <a:avLst/>
-          </a:prstGeom>
-          <a:noFill/>
-          <a:ln/>
-        </p:spPr>
-        <p:txBody>
-          <a:bodyPr wrap="square" lIns="0" tIns="0" rIns="0" bIns="0" rtlCol="0" anchor="ctr"/>
-          <a:lstStyle/>
-          <a:p>
-            <a:pPr indent="0" marL="0">
-              <a:buNone/>
-            </a:pPr>
-            <a:r>
-              <a:rPr lang="en-US" sz="2000" b="1" dirty="0">
-                <a:solidFill>
-                  <a:srgbClr val="F4F4F5"/>
+              <a:rPr lang="en-US" sz="10000" b="1" dirty="0">
+                <a:solidFill>
+                  <a:srgbClr val="3DDC97"/>
                 </a:solidFill>
                 <a:latin typeface="Arial" pitchFamily="34" charset="0"/>
                 <a:ea typeface="Arial" pitchFamily="34" charset="-122"/>
                 <a:cs typeface="Arial" pitchFamily="34" charset="-120"/>
               </a:rPr>
-              <a:t>Record</a:t>
-            </a:r>
-            <a:endParaRPr lang="en-US" sz="2000" dirty="0"/>
-          </a:p>
-        </p:txBody>
-      </p:sp>
-      <p:sp>
-        <p:nvSpPr>
-          <p:cNvPr id="9" name="Text 7"/>
-          <p:cNvSpPr/>
-          <p:nvPr/>
-        </p:nvSpPr>
-        <p:spPr>
-          <a:xfrm>
-            <a:off x="777240" y="2926080"/>
-            <a:ext cx="1965960" cy="960120"/>
+              <a:t>73%</a:t>
+            </a:r>
+            <a:endParaRPr lang="en-US" sz="10000" dirty="0"/>
+          </a:p>
+        </p:txBody>
+      </p:sp>
+      <p:sp>
+        <p:nvSpPr>
+          <p:cNvPr id="7" name="Text 5"/>
+          <p:cNvSpPr/>
+          <p:nvPr/>
+        </p:nvSpPr>
+        <p:spPr>
+          <a:xfrm>
+            <a:off x="548640" y="3291840"/>
+            <a:ext cx="4480560" cy="548640"/>
           </a:xfrm>
           <a:prstGeom prst="rect">
             <a:avLst/>
@@ -5326,7 +6137,7 @@
               <a:buNone/>
             </a:pPr>
             <a:r>
-              <a:rPr lang="en-US" sz="1200" dirty="0">
+              <a:rPr lang="en-US" sz="1400" dirty="0">
                 <a:solidFill>
                   <a:srgbClr val="A1A1AA"/>
                 </a:solidFill>
@@ -5334,38 +6145,38 @@
                 <a:ea typeface="Arial" pitchFamily="34" charset="-122"/>
                 <a:cs typeface="Arial" pitchFamily="34" charset="-120"/>
               </a:rPr>
-              <a:t>The brand's server signs it. The program sets the cut from the campaign rate.</a:t>
-            </a:r>
-            <a:endParaRPr lang="en-US" sz="1200" dirty="0"/>
-          </a:p>
-        </p:txBody>
-      </p:sp>
-      <p:sp>
-        <p:nvSpPr>
-          <p:cNvPr id="10" name="Text 8"/>
-          <p:cNvSpPr/>
-          <p:nvPr/>
-        </p:nvSpPr>
-        <p:spPr>
-          <a:xfrm>
-            <a:off x="2926080" y="2743200"/>
-            <a:ext cx="365760" cy="457200"/>
-          </a:xfrm>
-          <a:prstGeom prst="rect">
-            <a:avLst/>
-          </a:prstGeom>
-          <a:noFill/>
-          <a:ln/>
-        </p:spPr>
-        <p:txBody>
-          <a:bodyPr wrap="square" lIns="0" tIns="0" rIns="0" bIns="0" rtlCol="0" anchor="ctr"/>
-          <a:lstStyle/>
-          <a:p>
-            <a:pPr algn="ctr" indent="0" marL="0">
-              <a:buNone/>
-            </a:pPr>
-            <a:r>
-              <a:rPr lang="en-US" sz="2000" dirty="0">
+              <a:t>of affiliates in crypto, forex and gambling programs switch mainly over payout reliability</a:t>
+            </a:r>
+            <a:endParaRPr lang="en-US" sz="1400" dirty="0"/>
+          </a:p>
+        </p:txBody>
+      </p:sp>
+      <p:sp>
+        <p:nvSpPr>
+          <p:cNvPr id="8" name="Text 6"/>
+          <p:cNvSpPr/>
+          <p:nvPr/>
+        </p:nvSpPr>
+        <p:spPr>
+          <a:xfrm>
+            <a:off x="5257800" y="2240280"/>
+            <a:ext cx="3291840" cy="1097280"/>
+          </a:xfrm>
+          <a:prstGeom prst="rect">
+            <a:avLst/>
+          </a:prstGeom>
+          <a:noFill/>
+          <a:ln/>
+        </p:spPr>
+        <p:txBody>
+          <a:bodyPr wrap="square" lIns="0" tIns="0" rIns="0" bIns="0" rtlCol="0" anchor="t"/>
+          <a:lstStyle/>
+          <a:p>
+            <a:pPr indent="0" marL="0">
+              <a:buNone/>
+            </a:pPr>
+            <a:r>
+              <a:rPr lang="en-US" sz="1800" dirty="0">
                 <a:solidFill>
                   <a:srgbClr val="A1A1AA"/>
                 </a:solidFill>
@@ -5373,49 +6184,22 @@
                 <a:ea typeface="Arial" pitchFamily="34" charset="-122"/>
                 <a:cs typeface="Arial" pitchFamily="34" charset="-120"/>
               </a:rPr>
-              <a:t>→</a:t>
-            </a:r>
-            <a:endParaRPr lang="en-US" sz="2000" dirty="0"/>
-          </a:p>
-        </p:txBody>
-      </p:sp>
-      <p:sp>
-        <p:nvSpPr>
-          <p:cNvPr id="11" name="Shape 9"/>
-          <p:cNvSpPr/>
-          <p:nvPr/>
-        </p:nvSpPr>
-        <p:spPr>
-          <a:xfrm>
-            <a:off x="3291840" y="1965960"/>
-            <a:ext cx="2377440" cy="2057400"/>
-          </a:xfrm>
-          <a:prstGeom prst="roundRect">
-            <a:avLst>
-              <a:gd name="adj" fmla="val 4444"/>
-            </a:avLst>
-          </a:prstGeom>
-          <a:solidFill>
-            <a:srgbClr val="141417"/>
-          </a:solidFill>
-          <a:ln w="12700">
-            <a:solidFill>
-              <a:srgbClr val="27272A"/>
-            </a:solidFill>
-            <a:prstDash val="solid"/>
-          </a:ln>
-        </p:spPr>
-      </p:sp>
-      <p:sp>
-        <p:nvSpPr>
-          <p:cNvPr id="12" name="Text 10"/>
-          <p:cNvSpPr/>
-          <p:nvPr/>
-        </p:nvSpPr>
-        <p:spPr>
-          <a:xfrm>
-            <a:off x="3520440" y="2148840"/>
-            <a:ext cx="914400" cy="256032"/>
+              <a:t>On-chain reserved and paid totals let a brand prove it pays.</a:t>
+            </a:r>
+            <a:endParaRPr lang="en-US" sz="1800" dirty="0"/>
+          </a:p>
+        </p:txBody>
+      </p:sp>
+      <p:sp>
+        <p:nvSpPr>
+          <p:cNvPr id="9" name="Text 7"/>
+          <p:cNvSpPr/>
+          <p:nvPr/>
+        </p:nvSpPr>
+        <p:spPr>
+          <a:xfrm>
+            <a:off x="548640" y="4681728"/>
+            <a:ext cx="7589520" cy="274320"/>
           </a:xfrm>
           <a:prstGeom prst="rect">
             <a:avLst/>
@@ -5431,317 +6215,17 @@
               <a:buNone/>
             </a:pPr>
             <a:r>
-              <a:rPr lang="en-US" sz="1000" dirty="0">
-                <a:solidFill>
-                  <a:srgbClr val="A1A1AA"/>
-                </a:solidFill>
-                <a:latin typeface="Consolas" pitchFamily="34" charset="0"/>
-                <a:ea typeface="Consolas" pitchFamily="34" charset="-122"/>
-                <a:cs typeface="Consolas" pitchFamily="34" charset="-120"/>
-              </a:rPr>
-              <a:t>02</a:t>
-            </a:r>
-            <a:endParaRPr lang="en-US" sz="1000" dirty="0"/>
-          </a:p>
-        </p:txBody>
-      </p:sp>
-      <p:sp>
-        <p:nvSpPr>
-          <p:cNvPr id="13" name="Text 11"/>
-          <p:cNvSpPr/>
-          <p:nvPr/>
-        </p:nvSpPr>
-        <p:spPr>
-          <a:xfrm>
-            <a:off x="3520440" y="2468880"/>
-            <a:ext cx="1920240" cy="384048"/>
-          </a:xfrm>
-          <a:prstGeom prst="rect">
-            <a:avLst/>
-          </a:prstGeom>
-          <a:noFill/>
-          <a:ln/>
-        </p:spPr>
-        <p:txBody>
-          <a:bodyPr wrap="square" lIns="0" tIns="0" rIns="0" bIns="0" rtlCol="0" anchor="ctr"/>
-          <a:lstStyle/>
-          <a:p>
-            <a:pPr indent="0" marL="0">
-              <a:buNone/>
-            </a:pPr>
-            <a:r>
-              <a:rPr lang="en-US" sz="2000" b="1" dirty="0">
-                <a:solidFill>
-                  <a:srgbClr val="F5B544"/>
+              <a:rPr lang="en-US" sz="900" dirty="0">
+                <a:solidFill>
+                  <a:srgbClr val="71717A"/>
                 </a:solidFill>
                 <a:latin typeface="Arial" pitchFamily="34" charset="0"/>
                 <a:ea typeface="Arial" pitchFamily="34" charset="-122"/>
                 <a:cs typeface="Arial" pitchFamily="34" charset="-120"/>
               </a:rPr>
-              <a:t>Hold</a:t>
-            </a:r>
-            <a:endParaRPr lang="en-US" sz="2000" dirty="0"/>
-          </a:p>
-        </p:txBody>
-      </p:sp>
-      <p:sp>
-        <p:nvSpPr>
-          <p:cNvPr id="14" name="Text 12"/>
-          <p:cNvSpPr/>
-          <p:nvPr/>
-        </p:nvSpPr>
-        <p:spPr>
-          <a:xfrm>
-            <a:off x="3520440" y="2926080"/>
-            <a:ext cx="1965960" cy="960120"/>
-          </a:xfrm>
-          <a:prstGeom prst="rect">
-            <a:avLst/>
-          </a:prstGeom>
-          <a:noFill/>
-          <a:ln/>
-        </p:spPr>
-        <p:txBody>
-          <a:bodyPr wrap="square" lIns="0" tIns="0" rIns="0" bIns="0" rtlCol="0" anchor="t"/>
-          <a:lstStyle/>
-          <a:p>
-            <a:pPr indent="0" marL="0">
-              <a:buNone/>
-            </a:pPr>
-            <a:r>
-              <a:rPr lang="en-US" sz="1200" dirty="0">
-                <a:solidFill>
-                  <a:srgbClr val="A1A1AA"/>
-                </a:solidFill>
-                <a:latin typeface="Arial" pitchFamily="34" charset="0"/>
-                <a:ea typeface="Arial" pitchFamily="34" charset="-122"/>
-                <a:cs typeface="Arial" pitchFamily="34" charset="-120"/>
-              </a:rPr>
-              <a:t>A refund inside the window cancels it.</a:t>
-            </a:r>
-            <a:endParaRPr lang="en-US" sz="1200" dirty="0"/>
-          </a:p>
-        </p:txBody>
-      </p:sp>
-      <p:sp>
-        <p:nvSpPr>
-          <p:cNvPr id="15" name="Text 13"/>
-          <p:cNvSpPr/>
-          <p:nvPr/>
-        </p:nvSpPr>
-        <p:spPr>
-          <a:xfrm>
-            <a:off x="5669280" y="2743200"/>
-            <a:ext cx="365760" cy="457200"/>
-          </a:xfrm>
-          <a:prstGeom prst="rect">
-            <a:avLst/>
-          </a:prstGeom>
-          <a:noFill/>
-          <a:ln/>
-        </p:spPr>
-        <p:txBody>
-          <a:bodyPr wrap="square" lIns="0" tIns="0" rIns="0" bIns="0" rtlCol="0" anchor="ctr"/>
-          <a:lstStyle/>
-          <a:p>
-            <a:pPr algn="ctr" indent="0" marL="0">
-              <a:buNone/>
-            </a:pPr>
-            <a:r>
-              <a:rPr lang="en-US" sz="2000" dirty="0">
-                <a:solidFill>
-                  <a:srgbClr val="A1A1AA"/>
-                </a:solidFill>
-                <a:latin typeface="Arial" pitchFamily="34" charset="0"/>
-                <a:ea typeface="Arial" pitchFamily="34" charset="-122"/>
-                <a:cs typeface="Arial" pitchFamily="34" charset="-120"/>
-              </a:rPr>
-              <a:t>→</a:t>
-            </a:r>
-            <a:endParaRPr lang="en-US" sz="2000" dirty="0"/>
-          </a:p>
-        </p:txBody>
-      </p:sp>
-      <p:sp>
-        <p:nvSpPr>
-          <p:cNvPr id="16" name="Shape 14"/>
-          <p:cNvSpPr/>
-          <p:nvPr/>
-        </p:nvSpPr>
-        <p:spPr>
-          <a:xfrm>
-            <a:off x="6035040" y="1965960"/>
-            <a:ext cx="2377440" cy="2057400"/>
-          </a:xfrm>
-          <a:prstGeom prst="roundRect">
-            <a:avLst>
-              <a:gd name="adj" fmla="val 4444"/>
-            </a:avLst>
-          </a:prstGeom>
-          <a:solidFill>
-            <a:srgbClr val="141417"/>
-          </a:solidFill>
-          <a:ln w="19050">
-            <a:solidFill>
-              <a:srgbClr val="3DDC97"/>
-            </a:solidFill>
-            <a:prstDash val="solid"/>
-          </a:ln>
-        </p:spPr>
-      </p:sp>
-      <p:sp>
-        <p:nvSpPr>
-          <p:cNvPr id="17" name="Text 15"/>
-          <p:cNvSpPr/>
-          <p:nvPr/>
-        </p:nvSpPr>
-        <p:spPr>
-          <a:xfrm>
-            <a:off x="6263640" y="2148840"/>
-            <a:ext cx="914400" cy="256032"/>
-          </a:xfrm>
-          <a:prstGeom prst="rect">
-            <a:avLst/>
-          </a:prstGeom>
-          <a:noFill/>
-          <a:ln/>
-        </p:spPr>
-        <p:txBody>
-          <a:bodyPr wrap="square" lIns="0" tIns="0" rIns="0" bIns="0" rtlCol="0" anchor="ctr"/>
-          <a:lstStyle/>
-          <a:p>
-            <a:pPr indent="0" marL="0">
-              <a:buNone/>
-            </a:pPr>
-            <a:r>
-              <a:rPr lang="en-US" sz="1000" dirty="0">
-                <a:solidFill>
-                  <a:srgbClr val="A1A1AA"/>
-                </a:solidFill>
-                <a:latin typeface="Consolas" pitchFamily="34" charset="0"/>
-                <a:ea typeface="Consolas" pitchFamily="34" charset="-122"/>
-                <a:cs typeface="Consolas" pitchFamily="34" charset="-120"/>
-              </a:rPr>
-              <a:t>03</a:t>
-            </a:r>
-            <a:endParaRPr lang="en-US" sz="1000" dirty="0"/>
-          </a:p>
-        </p:txBody>
-      </p:sp>
-      <p:sp>
-        <p:nvSpPr>
-          <p:cNvPr id="18" name="Text 16"/>
-          <p:cNvSpPr/>
-          <p:nvPr/>
-        </p:nvSpPr>
-        <p:spPr>
-          <a:xfrm>
-            <a:off x="6263640" y="2468880"/>
-            <a:ext cx="1920240" cy="384048"/>
-          </a:xfrm>
-          <a:prstGeom prst="rect">
-            <a:avLst/>
-          </a:prstGeom>
-          <a:noFill/>
-          <a:ln/>
-        </p:spPr>
-        <p:txBody>
-          <a:bodyPr wrap="square" lIns="0" tIns="0" rIns="0" bIns="0" rtlCol="0" anchor="ctr"/>
-          <a:lstStyle/>
-          <a:p>
-            <a:pPr indent="0" marL="0">
-              <a:buNone/>
-            </a:pPr>
-            <a:r>
-              <a:rPr lang="en-US" sz="2000" b="1" dirty="0">
-                <a:solidFill>
-                  <a:srgbClr val="3DDC97"/>
-                </a:solidFill>
-                <a:latin typeface="Arial" pitchFamily="34" charset="0"/>
-                <a:ea typeface="Arial" pitchFamily="34" charset="-122"/>
-                <a:cs typeface="Arial" pitchFamily="34" charset="-120"/>
-              </a:rPr>
-              <a:t>Release</a:t>
-            </a:r>
-            <a:endParaRPr lang="en-US" sz="2000" dirty="0"/>
-          </a:p>
-        </p:txBody>
-      </p:sp>
-      <p:sp>
-        <p:nvSpPr>
-          <p:cNvPr id="19" name="Text 17"/>
-          <p:cNvSpPr/>
-          <p:nvPr/>
-        </p:nvSpPr>
-        <p:spPr>
-          <a:xfrm>
-            <a:off x="6263640" y="2926080"/>
-            <a:ext cx="1965960" cy="960120"/>
-          </a:xfrm>
-          <a:prstGeom prst="rect">
-            <a:avLst/>
-          </a:prstGeom>
-          <a:noFill/>
-          <a:ln/>
-        </p:spPr>
-        <p:txBody>
-          <a:bodyPr wrap="square" lIns="0" tIns="0" rIns="0" bIns="0" rtlCol="0" anchor="t"/>
-          <a:lstStyle/>
-          <a:p>
-            <a:pPr indent="0" marL="0">
-              <a:buNone/>
-            </a:pPr>
-            <a:r>
-              <a:rPr lang="en-US" sz="1200" dirty="0">
-                <a:solidFill>
-                  <a:srgbClr val="A1A1AA"/>
-                </a:solidFill>
-                <a:latin typeface="Arial" pitchFamily="34" charset="0"/>
-                <a:ea typeface="Arial" pitchFamily="34" charset="-122"/>
-                <a:cs typeface="Arial" pitchFamily="34" charset="-120"/>
-              </a:rPr>
-              <a:t>Anyone can trigger it. USDC goes only to the payee.</a:t>
-            </a:r>
-            <a:endParaRPr lang="en-US" sz="1200" dirty="0"/>
-          </a:p>
-        </p:txBody>
-      </p:sp>
-      <p:sp>
-        <p:nvSpPr>
-          <p:cNvPr id="20" name="Text 18"/>
-          <p:cNvSpPr/>
-          <p:nvPr/>
-        </p:nvSpPr>
-        <p:spPr>
-          <a:xfrm>
-            <a:off x="548640" y="4206240"/>
-            <a:ext cx="7680960" cy="274320"/>
-          </a:xfrm>
-          <a:prstGeom prst="rect">
-            <a:avLst/>
-          </a:prstGeom>
-          <a:noFill/>
-          <a:ln/>
-        </p:spPr>
-        <p:txBody>
-          <a:bodyPr wrap="square" lIns="0" tIns="0" rIns="0" bIns="0" rtlCol="0" anchor="ctr"/>
-          <a:lstStyle/>
-          <a:p>
-            <a:pPr indent="0" marL="0">
-              <a:buNone/>
-            </a:pPr>
-            <a:r>
-              <a:rPr lang="en-US" sz="1000" dirty="0">
-                <a:solidFill>
-                  <a:srgbClr val="71717A"/>
-                </a:solidFill>
-                <a:latin typeface="Consolas" pitchFamily="34" charset="0"/>
-                <a:ea typeface="Consolas" pitchFamily="34" charset="-122"/>
-                <a:cs typeface="Consolas" pitchFamily="34" charset="-120"/>
-              </a:rPr>
-              <a:t>record_sale  ·  cancel  ·  release</a:t>
-            </a:r>
-            <a:endParaRPr lang="en-US" sz="1000" dirty="0"/>
+              <a:t>Source: PerformanceIN 2025 survey of 3,200 affiliates, via TheFinRate [S8]</a:t>
+            </a:r>
+            <a:endParaRPr lang="en-US" sz="900" dirty="0"/>
           </a:p>
         </p:txBody>
       </p:sp>
@@ -5810,7 +6294,7 @@
                 <a:ea typeface="Arial" pitchFamily="34" charset="-122"/>
                 <a:cs typeface="Arial" pitchFamily="34" charset="-120"/>
               </a:rPr>
-              <a:t>EARLY PAYOUT</a:t>
+              <a:t>IN USE</a:t>
             </a:r>
             <a:endParaRPr lang="en-US" sz="1000" dirty="0"/>
           </a:p>
@@ -5851,7 +6335,7 @@
                 <a:ea typeface="Arial" pitchFamily="34" charset="-122"/>
                 <a:cs typeface="Arial" pitchFamily="34" charset="-120"/>
               </a:rPr>
-              <a:t>A creator who can't wait sells the commission for cash today.</a:t>
+              <a:t>Record the sale, hold it through the window, then release.</a:t>
             </a:r>
             <a:endParaRPr lang="en-US" sz="2800" dirty="0"/>
           </a:p>
@@ -5920,14 +6404,41 @@
       </p:sp>
       <p:sp>
         <p:nvSpPr>
-          <p:cNvPr id="6" name="Text 4"/>
-          <p:cNvSpPr/>
-          <p:nvPr/>
-        </p:nvSpPr>
-        <p:spPr>
-          <a:xfrm>
-            <a:off x="548640" y="2240280"/>
-            <a:ext cx="2103120" cy="384048"/>
+          <p:cNvPr id="6" name="Shape 4"/>
+          <p:cNvSpPr/>
+          <p:nvPr/>
+        </p:nvSpPr>
+        <p:spPr>
+          <a:xfrm>
+            <a:off x="548640" y="1965960"/>
+            <a:ext cx="2377440" cy="2057400"/>
+          </a:xfrm>
+          <a:prstGeom prst="roundRect">
+            <a:avLst>
+              <a:gd name="adj" fmla="val 4444"/>
+            </a:avLst>
+          </a:prstGeom>
+          <a:solidFill>
+            <a:srgbClr val="141417"/>
+          </a:solidFill>
+          <a:ln w="12700">
+            <a:solidFill>
+              <a:srgbClr val="27272A"/>
+            </a:solidFill>
+            <a:prstDash val="solid"/>
+          </a:ln>
+        </p:spPr>
+      </p:sp>
+      <p:sp>
+        <p:nvSpPr>
+          <p:cNvPr id="7" name="Text 5"/>
+          <p:cNvSpPr/>
+          <p:nvPr/>
+        </p:nvSpPr>
+        <p:spPr>
+          <a:xfrm>
+            <a:off x="777240" y="2148840"/>
+            <a:ext cx="914400" cy="256032"/>
           </a:xfrm>
           <a:prstGeom prst="rect">
             <a:avLst/>
@@ -5943,7 +6454,46 @@
               <a:buNone/>
             </a:pPr>
             <a:r>
-              <a:rPr lang="en-US" sz="1400" dirty="0">
+              <a:rPr lang="en-US" sz="1000" dirty="0">
+                <a:solidFill>
+                  <a:srgbClr val="A1A1AA"/>
+                </a:solidFill>
+                <a:latin typeface="Consolas" pitchFamily="34" charset="0"/>
+                <a:ea typeface="Consolas" pitchFamily="34" charset="-122"/>
+                <a:cs typeface="Consolas" pitchFamily="34" charset="-120"/>
+              </a:rPr>
+              <a:t>01</a:t>
+            </a:r>
+            <a:endParaRPr lang="en-US" sz="1000" dirty="0"/>
+          </a:p>
+        </p:txBody>
+      </p:sp>
+      <p:sp>
+        <p:nvSpPr>
+          <p:cNvPr id="8" name="Text 6"/>
+          <p:cNvSpPr/>
+          <p:nvPr/>
+        </p:nvSpPr>
+        <p:spPr>
+          <a:xfrm>
+            <a:off x="777240" y="2468880"/>
+            <a:ext cx="1920240" cy="384048"/>
+          </a:xfrm>
+          <a:prstGeom prst="rect">
+            <a:avLst/>
+          </a:prstGeom>
+          <a:noFill/>
+          <a:ln/>
+        </p:spPr>
+        <p:txBody>
+          <a:bodyPr wrap="square" lIns="0" tIns="0" rIns="0" bIns="0" rtlCol="0" anchor="ctr"/>
+          <a:lstStyle/>
+          <a:p>
+            <a:pPr indent="0" marL="0">
+              <a:buNone/>
+            </a:pPr>
+            <a:r>
+              <a:rPr lang="en-US" sz="2000" b="1" dirty="0">
                 <a:solidFill>
                   <a:srgbClr val="F4F4F5"/>
                 </a:solidFill>
@@ -5951,66 +6501,127 @@
                 <a:ea typeface="Arial" pitchFamily="34" charset="-122"/>
                 <a:cs typeface="Arial" pitchFamily="34" charset="-120"/>
               </a:rPr>
-              <a:t>Creator, paid today</a:t>
-            </a:r>
-            <a:endParaRPr lang="en-US" sz="1400" dirty="0"/>
-          </a:p>
-        </p:txBody>
-      </p:sp>
-      <p:sp>
-        <p:nvSpPr>
-          <p:cNvPr id="7" name="Shape 5"/>
-          <p:cNvSpPr/>
-          <p:nvPr/>
-        </p:nvSpPr>
-        <p:spPr>
-          <a:xfrm>
-            <a:off x="2697480" y="2267712"/>
-            <a:ext cx="4572000" cy="329184"/>
+              <a:t>Record</a:t>
+            </a:r>
+            <a:endParaRPr lang="en-US" sz="2000" dirty="0"/>
+          </a:p>
+        </p:txBody>
+      </p:sp>
+      <p:sp>
+        <p:nvSpPr>
+          <p:cNvPr id="9" name="Text 7"/>
+          <p:cNvSpPr/>
+          <p:nvPr/>
+        </p:nvSpPr>
+        <p:spPr>
+          <a:xfrm>
+            <a:off x="777240" y="2926080"/>
+            <a:ext cx="1965960" cy="960120"/>
+          </a:xfrm>
+          <a:prstGeom prst="rect">
+            <a:avLst/>
+          </a:prstGeom>
+          <a:noFill/>
+          <a:ln/>
+        </p:spPr>
+        <p:txBody>
+          <a:bodyPr wrap="square" lIns="0" tIns="0" rIns="0" bIns="0" rtlCol="0" anchor="t"/>
+          <a:lstStyle/>
+          <a:p>
+            <a:pPr indent="0" marL="0">
+              <a:buNone/>
+            </a:pPr>
+            <a:r>
+              <a:rPr lang="en-US" sz="1200" dirty="0">
+                <a:solidFill>
+                  <a:srgbClr val="A1A1AA"/>
+                </a:solidFill>
+                <a:latin typeface="Arial" pitchFamily="34" charset="0"/>
+                <a:ea typeface="Arial" pitchFamily="34" charset="-122"/>
+                <a:cs typeface="Arial" pitchFamily="34" charset="-120"/>
+              </a:rPr>
+              <a:t>The brand's server signs it. The program sets the cut from the campaign rate.</a:t>
+            </a:r>
+            <a:endParaRPr lang="en-US" sz="1200" dirty="0"/>
+          </a:p>
+        </p:txBody>
+      </p:sp>
+      <p:sp>
+        <p:nvSpPr>
+          <p:cNvPr id="10" name="Text 8"/>
+          <p:cNvSpPr/>
+          <p:nvPr/>
+        </p:nvSpPr>
+        <p:spPr>
+          <a:xfrm>
+            <a:off x="2926080" y="2743200"/>
+            <a:ext cx="365760" cy="457200"/>
+          </a:xfrm>
+          <a:prstGeom prst="rect">
+            <a:avLst/>
+          </a:prstGeom>
+          <a:noFill/>
+          <a:ln/>
+        </p:spPr>
+        <p:txBody>
+          <a:bodyPr wrap="square" lIns="0" tIns="0" rIns="0" bIns="0" rtlCol="0" anchor="ctr"/>
+          <a:lstStyle/>
+          <a:p>
+            <a:pPr algn="ctr" indent="0" marL="0">
+              <a:buNone/>
+            </a:pPr>
+            <a:r>
+              <a:rPr lang="en-US" sz="2000" dirty="0">
+                <a:solidFill>
+                  <a:srgbClr val="A1A1AA"/>
+                </a:solidFill>
+                <a:latin typeface="Arial" pitchFamily="34" charset="0"/>
+                <a:ea typeface="Arial" pitchFamily="34" charset="-122"/>
+                <a:cs typeface="Arial" pitchFamily="34" charset="-120"/>
+              </a:rPr>
+              <a:t>→</a:t>
+            </a:r>
+            <a:endParaRPr lang="en-US" sz="2000" dirty="0"/>
+          </a:p>
+        </p:txBody>
+      </p:sp>
+      <p:sp>
+        <p:nvSpPr>
+          <p:cNvPr id="11" name="Shape 9"/>
+          <p:cNvSpPr/>
+          <p:nvPr/>
+        </p:nvSpPr>
+        <p:spPr>
+          <a:xfrm>
+            <a:off x="3291840" y="1965960"/>
+            <a:ext cx="2377440" cy="2057400"/>
           </a:xfrm>
           <a:prstGeom prst="roundRect">
             <a:avLst>
-              <a:gd name="adj" fmla="val 13889"/>
+              <a:gd name="adj" fmla="val 4444"/>
             </a:avLst>
           </a:prstGeom>
           <a:solidFill>
             <a:srgbClr val="141417"/>
           </a:solidFill>
-          <a:ln/>
-        </p:spPr>
-      </p:sp>
-      <p:sp>
-        <p:nvSpPr>
-          <p:cNvPr id="8" name="Shape 6"/>
-          <p:cNvSpPr/>
-          <p:nvPr/>
-        </p:nvSpPr>
-        <p:spPr>
-          <a:xfrm>
-            <a:off x="2697480" y="2267712"/>
-            <a:ext cx="4434840" cy="329184"/>
-          </a:xfrm>
-          <a:prstGeom prst="roundRect">
-            <a:avLst>
-              <a:gd name="adj" fmla="val 13889"/>
-            </a:avLst>
-          </a:prstGeom>
-          <a:solidFill>
-            <a:srgbClr val="3DDC97"/>
-          </a:solidFill>
-          <a:ln/>
-        </p:spPr>
-      </p:sp>
-      <p:sp>
-        <p:nvSpPr>
-          <p:cNvPr id="9" name="Text 7"/>
-          <p:cNvSpPr/>
-          <p:nvPr/>
-        </p:nvSpPr>
-        <p:spPr>
-          <a:xfrm>
-            <a:off x="7406640" y="2240280"/>
-            <a:ext cx="1280160" cy="384048"/>
+          <a:ln w="12700">
+            <a:solidFill>
+              <a:srgbClr val="27272A"/>
+            </a:solidFill>
+            <a:prstDash val="solid"/>
+          </a:ln>
+        </p:spPr>
+      </p:sp>
+      <p:sp>
+        <p:nvSpPr>
+          <p:cNvPr id="12" name="Text 10"/>
+          <p:cNvSpPr/>
+          <p:nvPr/>
+        </p:nvSpPr>
+        <p:spPr>
+          <a:xfrm>
+            <a:off x="3520440" y="2148840"/>
+            <a:ext cx="914400" cy="256032"/>
           </a:xfrm>
           <a:prstGeom prst="rect">
             <a:avLst/>
@@ -6026,30 +6637,30 @@
               <a:buNone/>
             </a:pPr>
             <a:r>
-              <a:rPr lang="en-US" sz="1400" b="1" dirty="0">
-                <a:solidFill>
-                  <a:srgbClr val="F4F4F5"/>
+              <a:rPr lang="en-US" sz="1000" dirty="0">
+                <a:solidFill>
+                  <a:srgbClr val="A1A1AA"/>
                 </a:solidFill>
                 <a:latin typeface="Consolas" pitchFamily="34" charset="0"/>
                 <a:ea typeface="Consolas" pitchFamily="34" charset="-122"/>
                 <a:cs typeface="Consolas" pitchFamily="34" charset="-120"/>
               </a:rPr>
-              <a:t>24.25 USDC</a:t>
-            </a:r>
-            <a:endParaRPr lang="en-US" sz="1400" dirty="0"/>
-          </a:p>
-        </p:txBody>
-      </p:sp>
-      <p:sp>
-        <p:nvSpPr>
-          <p:cNvPr id="10" name="Text 8"/>
-          <p:cNvSpPr/>
-          <p:nvPr/>
-        </p:nvSpPr>
-        <p:spPr>
-          <a:xfrm>
-            <a:off x="548640" y="2971800"/>
-            <a:ext cx="2103120" cy="384048"/>
+              <a:t>02</a:t>
+            </a:r>
+            <a:endParaRPr lang="en-US" sz="1000" dirty="0"/>
+          </a:p>
+        </p:txBody>
+      </p:sp>
+      <p:sp>
+        <p:nvSpPr>
+          <p:cNvPr id="13" name="Text 11"/>
+          <p:cNvSpPr/>
+          <p:nvPr/>
+        </p:nvSpPr>
+        <p:spPr>
+          <a:xfrm>
+            <a:off x="3520440" y="2468880"/>
+            <a:ext cx="1920240" cy="384048"/>
           </a:xfrm>
           <a:prstGeom prst="rect">
             <a:avLst/>
@@ -6065,74 +6676,135 @@
               <a:buNone/>
             </a:pPr>
             <a:r>
-              <a:rPr lang="en-US" sz="1400" dirty="0">
-                <a:solidFill>
-                  <a:srgbClr val="F4F4F5"/>
+              <a:rPr lang="en-US" sz="2000" b="1" dirty="0">
+                <a:solidFill>
+                  <a:srgbClr val="F5B544"/>
                 </a:solidFill>
                 <a:latin typeface="Arial" pitchFamily="34" charset="0"/>
                 <a:ea typeface="Arial" pitchFamily="34" charset="-122"/>
                 <a:cs typeface="Arial" pitchFamily="34" charset="-120"/>
               </a:rPr>
-              <a:t>Buyer, paid at release</a:t>
-            </a:r>
-            <a:endParaRPr lang="en-US" sz="1400" dirty="0"/>
-          </a:p>
-        </p:txBody>
-      </p:sp>
-      <p:sp>
-        <p:nvSpPr>
-          <p:cNvPr id="11" name="Shape 9"/>
-          <p:cNvSpPr/>
-          <p:nvPr/>
-        </p:nvSpPr>
-        <p:spPr>
-          <a:xfrm>
-            <a:off x="2697480" y="2999232"/>
-            <a:ext cx="4572000" cy="329184"/>
+              <a:t>Hold</a:t>
+            </a:r>
+            <a:endParaRPr lang="en-US" sz="2000" dirty="0"/>
+          </a:p>
+        </p:txBody>
+      </p:sp>
+      <p:sp>
+        <p:nvSpPr>
+          <p:cNvPr id="14" name="Text 12"/>
+          <p:cNvSpPr/>
+          <p:nvPr/>
+        </p:nvSpPr>
+        <p:spPr>
+          <a:xfrm>
+            <a:off x="3520440" y="2926080"/>
+            <a:ext cx="1965960" cy="960120"/>
+          </a:xfrm>
+          <a:prstGeom prst="rect">
+            <a:avLst/>
+          </a:prstGeom>
+          <a:noFill/>
+          <a:ln/>
+        </p:spPr>
+        <p:txBody>
+          <a:bodyPr wrap="square" lIns="0" tIns="0" rIns="0" bIns="0" rtlCol="0" anchor="t"/>
+          <a:lstStyle/>
+          <a:p>
+            <a:pPr indent="0" marL="0">
+              <a:buNone/>
+            </a:pPr>
+            <a:r>
+              <a:rPr lang="en-US" sz="1200" dirty="0">
+                <a:solidFill>
+                  <a:srgbClr val="A1A1AA"/>
+                </a:solidFill>
+                <a:latin typeface="Arial" pitchFamily="34" charset="0"/>
+                <a:ea typeface="Arial" pitchFamily="34" charset="-122"/>
+                <a:cs typeface="Arial" pitchFamily="34" charset="-120"/>
+              </a:rPr>
+              <a:t>A refund inside the window cancels it.</a:t>
+            </a:r>
+            <a:endParaRPr lang="en-US" sz="1200" dirty="0"/>
+          </a:p>
+        </p:txBody>
+      </p:sp>
+      <p:sp>
+        <p:nvSpPr>
+          <p:cNvPr id="15" name="Text 13"/>
+          <p:cNvSpPr/>
+          <p:nvPr/>
+        </p:nvSpPr>
+        <p:spPr>
+          <a:xfrm>
+            <a:off x="5669280" y="2743200"/>
+            <a:ext cx="365760" cy="457200"/>
+          </a:xfrm>
+          <a:prstGeom prst="rect">
+            <a:avLst/>
+          </a:prstGeom>
+          <a:noFill/>
+          <a:ln/>
+        </p:spPr>
+        <p:txBody>
+          <a:bodyPr wrap="square" lIns="0" tIns="0" rIns="0" bIns="0" rtlCol="0" anchor="ctr"/>
+          <a:lstStyle/>
+          <a:p>
+            <a:pPr algn="ctr" indent="0" marL="0">
+              <a:buNone/>
+            </a:pPr>
+            <a:r>
+              <a:rPr lang="en-US" sz="2000" dirty="0">
+                <a:solidFill>
+                  <a:srgbClr val="A1A1AA"/>
+                </a:solidFill>
+                <a:latin typeface="Arial" pitchFamily="34" charset="0"/>
+                <a:ea typeface="Arial" pitchFamily="34" charset="-122"/>
+                <a:cs typeface="Arial" pitchFamily="34" charset="-120"/>
+              </a:rPr>
+              <a:t>→</a:t>
+            </a:r>
+            <a:endParaRPr lang="en-US" sz="2000" dirty="0"/>
+          </a:p>
+        </p:txBody>
+      </p:sp>
+      <p:sp>
+        <p:nvSpPr>
+          <p:cNvPr id="16" name="Shape 14"/>
+          <p:cNvSpPr/>
+          <p:nvPr/>
+        </p:nvSpPr>
+        <p:spPr>
+          <a:xfrm>
+            <a:off x="6035040" y="1965960"/>
+            <a:ext cx="2377440" cy="2057400"/>
           </a:xfrm>
           <a:prstGeom prst="roundRect">
             <a:avLst>
-              <a:gd name="adj" fmla="val 13889"/>
+              <a:gd name="adj" fmla="val 4444"/>
             </a:avLst>
           </a:prstGeom>
           <a:solidFill>
             <a:srgbClr val="141417"/>
           </a:solidFill>
-          <a:ln/>
-        </p:spPr>
-      </p:sp>
-      <p:sp>
-        <p:nvSpPr>
-          <p:cNvPr id="12" name="Shape 10"/>
-          <p:cNvSpPr/>
-          <p:nvPr/>
-        </p:nvSpPr>
-        <p:spPr>
-          <a:xfrm>
-            <a:off x="2697480" y="2999232"/>
-            <a:ext cx="4572000" cy="329184"/>
-          </a:xfrm>
-          <a:prstGeom prst="roundRect">
-            <a:avLst>
-              <a:gd name="adj" fmla="val 13889"/>
-            </a:avLst>
-          </a:prstGeom>
-          <a:solidFill>
-            <a:srgbClr val="52525B"/>
-          </a:solidFill>
-          <a:ln/>
-        </p:spPr>
-      </p:sp>
-      <p:sp>
-        <p:nvSpPr>
-          <p:cNvPr id="13" name="Text 11"/>
-          <p:cNvSpPr/>
-          <p:nvPr/>
-        </p:nvSpPr>
-        <p:spPr>
-          <a:xfrm>
-            <a:off x="7406640" y="2971800"/>
-            <a:ext cx="1280160" cy="384048"/>
+          <a:ln w="19050">
+            <a:solidFill>
+              <a:srgbClr val="3DDC97"/>
+            </a:solidFill>
+            <a:prstDash val="solid"/>
+          </a:ln>
+        </p:spPr>
+      </p:sp>
+      <p:sp>
+        <p:nvSpPr>
+          <p:cNvPr id="17" name="Text 15"/>
+          <p:cNvSpPr/>
+          <p:nvPr/>
+        </p:nvSpPr>
+        <p:spPr>
+          <a:xfrm>
+            <a:off x="6263640" y="2148840"/>
+            <a:ext cx="914400" cy="256032"/>
           </a:xfrm>
           <a:prstGeom prst="rect">
             <a:avLst/>
@@ -6148,30 +6820,30 @@
               <a:buNone/>
             </a:pPr>
             <a:r>
-              <a:rPr lang="en-US" sz="1400" b="1" dirty="0">
-                <a:solidFill>
-                  <a:srgbClr val="F4F4F5"/>
+              <a:rPr lang="en-US" sz="1000" dirty="0">
+                <a:solidFill>
+                  <a:srgbClr val="A1A1AA"/>
                 </a:solidFill>
                 <a:latin typeface="Consolas" pitchFamily="34" charset="0"/>
                 <a:ea typeface="Consolas" pitchFamily="34" charset="-122"/>
                 <a:cs typeface="Consolas" pitchFamily="34" charset="-120"/>
               </a:rPr>
-              <a:t>25.00 USDC</a:t>
-            </a:r>
-            <a:endParaRPr lang="en-US" sz="1400" dirty="0"/>
-          </a:p>
-        </p:txBody>
-      </p:sp>
-      <p:sp>
-        <p:nvSpPr>
-          <p:cNvPr id="14" name="Text 12"/>
-          <p:cNvSpPr/>
-          <p:nvPr/>
-        </p:nvSpPr>
-        <p:spPr>
-          <a:xfrm>
-            <a:off x="2697480" y="3840480"/>
-            <a:ext cx="5486400" cy="320040"/>
+              <a:t>03</a:t>
+            </a:r>
+            <a:endParaRPr lang="en-US" sz="1000" dirty="0"/>
+          </a:p>
+        </p:txBody>
+      </p:sp>
+      <p:sp>
+        <p:nvSpPr>
+          <p:cNvPr id="18" name="Text 16"/>
+          <p:cNvSpPr/>
+          <p:nvPr/>
+        </p:nvSpPr>
+        <p:spPr>
+          <a:xfrm>
+            <a:off x="6263640" y="2468880"/>
+            <a:ext cx="1920240" cy="384048"/>
           </a:xfrm>
           <a:prstGeom prst="rect">
             <a:avLst/>
@@ -6187,56 +6859,95 @@
               <a:buNone/>
             </a:pPr>
             <a:r>
-              <a:rPr lang="en-US" sz="1200" dirty="0">
-                <a:solidFill>
-                  <a:srgbClr val="A1A1AA"/>
+              <a:rPr lang="en-US" sz="2000" b="1" dirty="0">
+                <a:solidFill>
+                  <a:srgbClr val="3DDC97"/>
                 </a:solidFill>
                 <a:latin typeface="Arial" pitchFamily="34" charset="0"/>
                 <a:ea typeface="Arial" pitchFamily="34" charset="-122"/>
                 <a:cs typeface="Arial" pitchFamily="34" charset="-120"/>
               </a:rPr>
-              <a:t>The buyer becomes the payee and carries the refund risk.</a:t>
-            </a:r>
-            <a:endParaRPr lang="en-US" sz="1200" dirty="0"/>
-          </a:p>
-        </p:txBody>
-      </p:sp>
-      <p:sp>
-        <p:nvSpPr>
-          <p:cNvPr id="15" name="Text 13"/>
-          <p:cNvSpPr/>
-          <p:nvPr/>
-        </p:nvSpPr>
-        <p:spPr>
-          <a:xfrm>
-            <a:off x="548640" y="4681728"/>
-            <a:ext cx="7589520" cy="274320"/>
-          </a:xfrm>
-          <a:prstGeom prst="rect">
-            <a:avLst/>
-          </a:prstGeom>
-          <a:noFill/>
-          <a:ln/>
-        </p:spPr>
-        <p:txBody>
-          <a:bodyPr wrap="square" lIns="0" tIns="0" rIns="0" bIns="0" rtlCol="0" anchor="ctr"/>
+              <a:t>Release</a:t>
+            </a:r>
+            <a:endParaRPr lang="en-US" sz="2000" dirty="0"/>
+          </a:p>
+        </p:txBody>
+      </p:sp>
+      <p:sp>
+        <p:nvSpPr>
+          <p:cNvPr id="19" name="Text 17"/>
+          <p:cNvSpPr/>
+          <p:nvPr/>
+        </p:nvSpPr>
+        <p:spPr>
+          <a:xfrm>
+            <a:off x="6263640" y="2926080"/>
+            <a:ext cx="1965960" cy="960120"/>
+          </a:xfrm>
+          <a:prstGeom prst="rect">
+            <a:avLst/>
+          </a:prstGeom>
+          <a:noFill/>
+          <a:ln/>
+        </p:spPr>
+        <p:txBody>
+          <a:bodyPr wrap="square" lIns="0" tIns="0" rIns="0" bIns="0" rtlCol="0" anchor="t"/>
           <a:lstStyle/>
           <a:p>
             <a:pPr indent="0" marL="0">
               <a:buNone/>
             </a:pPr>
             <a:r>
-              <a:rPr lang="en-US" sz="900" dirty="0">
-                <a:solidFill>
-                  <a:srgbClr val="71717A"/>
+              <a:rPr lang="en-US" sz="1200" dirty="0">
+                <a:solidFill>
+                  <a:srgbClr val="A1A1AA"/>
                 </a:solidFill>
                 <a:latin typeface="Arial" pitchFamily="34" charset="0"/>
                 <a:ea typeface="Arial" pitchFamily="34" charset="-122"/>
                 <a:cs typeface="Arial" pitchFamily="34" charset="-120"/>
               </a:rPr>
-              <a:t>Example: a 25.00 USDC commission sold at a 3% discount. Illustration, not outside data.</a:t>
-            </a:r>
-            <a:endParaRPr lang="en-US" sz="900" dirty="0"/>
+              <a:t>Anyone can trigger it. USDC goes only to the payee.</a:t>
+            </a:r>
+            <a:endParaRPr lang="en-US" sz="1200" dirty="0"/>
+          </a:p>
+        </p:txBody>
+      </p:sp>
+      <p:sp>
+        <p:nvSpPr>
+          <p:cNvPr id="20" name="Text 18"/>
+          <p:cNvSpPr/>
+          <p:nvPr/>
+        </p:nvSpPr>
+        <p:spPr>
+          <a:xfrm>
+            <a:off x="548640" y="4206240"/>
+            <a:ext cx="7680960" cy="274320"/>
+          </a:xfrm>
+          <a:prstGeom prst="rect">
+            <a:avLst/>
+          </a:prstGeom>
+          <a:noFill/>
+          <a:ln/>
+        </p:spPr>
+        <p:txBody>
+          <a:bodyPr wrap="square" lIns="0" tIns="0" rIns="0" bIns="0" rtlCol="0" anchor="ctr"/>
+          <a:lstStyle/>
+          <a:p>
+            <a:pPr indent="0" marL="0">
+              <a:buNone/>
+            </a:pPr>
+            <a:r>
+              <a:rPr lang="en-US" sz="1000" dirty="0">
+                <a:solidFill>
+                  <a:srgbClr val="71717A"/>
+                </a:solidFill>
+                <a:latin typeface="Consolas" pitchFamily="34" charset="0"/>
+                <a:ea typeface="Consolas" pitchFamily="34" charset="-122"/>
+                <a:cs typeface="Consolas" pitchFamily="34" charset="-120"/>
+              </a:rPr>
+              <a:t>record_sale  ·  cancel  ·  release</a:t>
+            </a:r>
+            <a:endParaRPr lang="en-US" sz="1000" dirty="0"/>
           </a:p>
         </p:txBody>
       </p:sp>
@@ -6305,7 +7016,7 @@
                 <a:ea typeface="Arial" pitchFamily="34" charset="-122"/>
                 <a:cs typeface="Arial" pitchFamily="34" charset="-120"/>
               </a:rPr>
-              <a:t>HOW IT WORKS</a:t>
+              <a:t>EARLY PAYOUT</a:t>
             </a:r>
             <a:endParaRPr lang="en-US" sz="1000" dirty="0"/>
           </a:p>
@@ -6346,7 +7057,7 @@
                 <a:ea typeface="Arial" pitchFamily="34" charset="-122"/>
                 <a:cs typeface="Arial" pitchFamily="34" charset="-120"/>
               </a:rPr>
-              <a:t>One 9,296-byte program enforces the rules, and 26 tests attack them.</a:t>
+              <a:t>A creator who can't wait sells the commission for cash today.</a:t>
             </a:r>
             <a:endParaRPr lang="en-US" sz="2800" dirty="0"/>
           </a:p>
@@ -6413,9 +7124,504 @@
           </a:p>
         </p:txBody>
       </p:sp>
+      <p:sp>
+        <p:nvSpPr>
+          <p:cNvPr id="6" name="Text 4"/>
+          <p:cNvSpPr/>
+          <p:nvPr/>
+        </p:nvSpPr>
+        <p:spPr>
+          <a:xfrm>
+            <a:off x="548640" y="2240280"/>
+            <a:ext cx="2103120" cy="384048"/>
+          </a:xfrm>
+          <a:prstGeom prst="rect">
+            <a:avLst/>
+          </a:prstGeom>
+          <a:noFill/>
+          <a:ln/>
+        </p:spPr>
+        <p:txBody>
+          <a:bodyPr wrap="square" lIns="0" tIns="0" rIns="0" bIns="0" rtlCol="0" anchor="ctr"/>
+          <a:lstStyle/>
+          <a:p>
+            <a:pPr indent="0" marL="0">
+              <a:buNone/>
+            </a:pPr>
+            <a:r>
+              <a:rPr lang="en-US" sz="1400" dirty="0">
+                <a:solidFill>
+                  <a:srgbClr val="F4F4F5"/>
+                </a:solidFill>
+                <a:latin typeface="Arial" pitchFamily="34" charset="0"/>
+                <a:ea typeface="Arial" pitchFamily="34" charset="-122"/>
+                <a:cs typeface="Arial" pitchFamily="34" charset="-120"/>
+              </a:rPr>
+              <a:t>Creator, paid today</a:t>
+            </a:r>
+            <a:endParaRPr lang="en-US" sz="1400" dirty="0"/>
+          </a:p>
+        </p:txBody>
+      </p:sp>
+      <p:sp>
+        <p:nvSpPr>
+          <p:cNvPr id="7" name="Shape 5"/>
+          <p:cNvSpPr/>
+          <p:nvPr/>
+        </p:nvSpPr>
+        <p:spPr>
+          <a:xfrm>
+            <a:off x="2697480" y="2267712"/>
+            <a:ext cx="4572000" cy="329184"/>
+          </a:xfrm>
+          <a:prstGeom prst="roundRect">
+            <a:avLst>
+              <a:gd name="adj" fmla="val 13889"/>
+            </a:avLst>
+          </a:prstGeom>
+          <a:solidFill>
+            <a:srgbClr val="141417"/>
+          </a:solidFill>
+          <a:ln/>
+        </p:spPr>
+      </p:sp>
+      <p:sp>
+        <p:nvSpPr>
+          <p:cNvPr id="8" name="Shape 6"/>
+          <p:cNvSpPr/>
+          <p:nvPr/>
+        </p:nvSpPr>
+        <p:spPr>
+          <a:xfrm>
+            <a:off x="2697480" y="2267712"/>
+            <a:ext cx="4434840" cy="329184"/>
+          </a:xfrm>
+          <a:prstGeom prst="roundRect">
+            <a:avLst>
+              <a:gd name="adj" fmla="val 13889"/>
+            </a:avLst>
+          </a:prstGeom>
+          <a:solidFill>
+            <a:srgbClr val="3DDC97"/>
+          </a:solidFill>
+          <a:ln/>
+        </p:spPr>
+      </p:sp>
+      <p:sp>
+        <p:nvSpPr>
+          <p:cNvPr id="9" name="Text 7"/>
+          <p:cNvSpPr/>
+          <p:nvPr/>
+        </p:nvSpPr>
+        <p:spPr>
+          <a:xfrm>
+            <a:off x="7406640" y="2240280"/>
+            <a:ext cx="1280160" cy="384048"/>
+          </a:xfrm>
+          <a:prstGeom prst="rect">
+            <a:avLst/>
+          </a:prstGeom>
+          <a:noFill/>
+          <a:ln/>
+        </p:spPr>
+        <p:txBody>
+          <a:bodyPr wrap="square" lIns="0" tIns="0" rIns="0" bIns="0" rtlCol="0" anchor="ctr"/>
+          <a:lstStyle/>
+          <a:p>
+            <a:pPr indent="0" marL="0">
+              <a:buNone/>
+            </a:pPr>
+            <a:r>
+              <a:rPr lang="en-US" sz="1400" b="1" dirty="0">
+                <a:solidFill>
+                  <a:srgbClr val="F4F4F5"/>
+                </a:solidFill>
+                <a:latin typeface="Consolas" pitchFamily="34" charset="0"/>
+                <a:ea typeface="Consolas" pitchFamily="34" charset="-122"/>
+                <a:cs typeface="Consolas" pitchFamily="34" charset="-120"/>
+              </a:rPr>
+              <a:t>24.25 USDC</a:t>
+            </a:r>
+            <a:endParaRPr lang="en-US" sz="1400" dirty="0"/>
+          </a:p>
+        </p:txBody>
+      </p:sp>
+      <p:sp>
+        <p:nvSpPr>
+          <p:cNvPr id="10" name="Text 8"/>
+          <p:cNvSpPr/>
+          <p:nvPr/>
+        </p:nvSpPr>
+        <p:spPr>
+          <a:xfrm>
+            <a:off x="548640" y="2971800"/>
+            <a:ext cx="2103120" cy="384048"/>
+          </a:xfrm>
+          <a:prstGeom prst="rect">
+            <a:avLst/>
+          </a:prstGeom>
+          <a:noFill/>
+          <a:ln/>
+        </p:spPr>
+        <p:txBody>
+          <a:bodyPr wrap="square" lIns="0" tIns="0" rIns="0" bIns="0" rtlCol="0" anchor="ctr"/>
+          <a:lstStyle/>
+          <a:p>
+            <a:pPr indent="0" marL="0">
+              <a:buNone/>
+            </a:pPr>
+            <a:r>
+              <a:rPr lang="en-US" sz="1400" dirty="0">
+                <a:solidFill>
+                  <a:srgbClr val="F4F4F5"/>
+                </a:solidFill>
+                <a:latin typeface="Arial" pitchFamily="34" charset="0"/>
+                <a:ea typeface="Arial" pitchFamily="34" charset="-122"/>
+                <a:cs typeface="Arial" pitchFamily="34" charset="-120"/>
+              </a:rPr>
+              <a:t>Buyer, paid at release</a:t>
+            </a:r>
+            <a:endParaRPr lang="en-US" sz="1400" dirty="0"/>
+          </a:p>
+        </p:txBody>
+      </p:sp>
+      <p:sp>
+        <p:nvSpPr>
+          <p:cNvPr id="11" name="Shape 9"/>
+          <p:cNvSpPr/>
+          <p:nvPr/>
+        </p:nvSpPr>
+        <p:spPr>
+          <a:xfrm>
+            <a:off x="2697480" y="2999232"/>
+            <a:ext cx="4572000" cy="329184"/>
+          </a:xfrm>
+          <a:prstGeom prst="roundRect">
+            <a:avLst>
+              <a:gd name="adj" fmla="val 13889"/>
+            </a:avLst>
+          </a:prstGeom>
+          <a:solidFill>
+            <a:srgbClr val="141417"/>
+          </a:solidFill>
+          <a:ln/>
+        </p:spPr>
+      </p:sp>
+      <p:sp>
+        <p:nvSpPr>
+          <p:cNvPr id="12" name="Shape 10"/>
+          <p:cNvSpPr/>
+          <p:nvPr/>
+        </p:nvSpPr>
+        <p:spPr>
+          <a:xfrm>
+            <a:off x="2697480" y="2999232"/>
+            <a:ext cx="4572000" cy="329184"/>
+          </a:xfrm>
+          <a:prstGeom prst="roundRect">
+            <a:avLst>
+              <a:gd name="adj" fmla="val 13889"/>
+            </a:avLst>
+          </a:prstGeom>
+          <a:solidFill>
+            <a:srgbClr val="52525B"/>
+          </a:solidFill>
+          <a:ln/>
+        </p:spPr>
+      </p:sp>
+      <p:sp>
+        <p:nvSpPr>
+          <p:cNvPr id="13" name="Text 11"/>
+          <p:cNvSpPr/>
+          <p:nvPr/>
+        </p:nvSpPr>
+        <p:spPr>
+          <a:xfrm>
+            <a:off x="7406640" y="2971800"/>
+            <a:ext cx="1280160" cy="384048"/>
+          </a:xfrm>
+          <a:prstGeom prst="rect">
+            <a:avLst/>
+          </a:prstGeom>
+          <a:noFill/>
+          <a:ln/>
+        </p:spPr>
+        <p:txBody>
+          <a:bodyPr wrap="square" lIns="0" tIns="0" rIns="0" bIns="0" rtlCol="0" anchor="ctr"/>
+          <a:lstStyle/>
+          <a:p>
+            <a:pPr indent="0" marL="0">
+              <a:buNone/>
+            </a:pPr>
+            <a:r>
+              <a:rPr lang="en-US" sz="1400" b="1" dirty="0">
+                <a:solidFill>
+                  <a:srgbClr val="F4F4F5"/>
+                </a:solidFill>
+                <a:latin typeface="Consolas" pitchFamily="34" charset="0"/>
+                <a:ea typeface="Consolas" pitchFamily="34" charset="-122"/>
+                <a:cs typeface="Consolas" pitchFamily="34" charset="-120"/>
+              </a:rPr>
+              <a:t>25.00 USDC</a:t>
+            </a:r>
+            <a:endParaRPr lang="en-US" sz="1400" dirty="0"/>
+          </a:p>
+        </p:txBody>
+      </p:sp>
+      <p:sp>
+        <p:nvSpPr>
+          <p:cNvPr id="14" name="Text 12"/>
+          <p:cNvSpPr/>
+          <p:nvPr/>
+        </p:nvSpPr>
+        <p:spPr>
+          <a:xfrm>
+            <a:off x="2697480" y="3840480"/>
+            <a:ext cx="5486400" cy="320040"/>
+          </a:xfrm>
+          <a:prstGeom prst="rect">
+            <a:avLst/>
+          </a:prstGeom>
+          <a:noFill/>
+          <a:ln/>
+        </p:spPr>
+        <p:txBody>
+          <a:bodyPr wrap="square" lIns="0" tIns="0" rIns="0" bIns="0" rtlCol="0" anchor="ctr"/>
+          <a:lstStyle/>
+          <a:p>
+            <a:pPr indent="0" marL="0">
+              <a:buNone/>
+            </a:pPr>
+            <a:r>
+              <a:rPr lang="en-US" sz="1200" dirty="0">
+                <a:solidFill>
+                  <a:srgbClr val="A1A1AA"/>
+                </a:solidFill>
+                <a:latin typeface="Arial" pitchFamily="34" charset="0"/>
+                <a:ea typeface="Arial" pitchFamily="34" charset="-122"/>
+                <a:cs typeface="Arial" pitchFamily="34" charset="-120"/>
+              </a:rPr>
+              <a:t>The buyer becomes the payee and carries the refund risk.</a:t>
+            </a:r>
+            <a:endParaRPr lang="en-US" sz="1200" dirty="0"/>
+          </a:p>
+        </p:txBody>
+      </p:sp>
+      <p:sp>
+        <p:nvSpPr>
+          <p:cNvPr id="15" name="Text 13"/>
+          <p:cNvSpPr/>
+          <p:nvPr/>
+        </p:nvSpPr>
+        <p:spPr>
+          <a:xfrm>
+            <a:off x="548640" y="4681728"/>
+            <a:ext cx="7589520" cy="274320"/>
+          </a:xfrm>
+          <a:prstGeom prst="rect">
+            <a:avLst/>
+          </a:prstGeom>
+          <a:noFill/>
+          <a:ln/>
+        </p:spPr>
+        <p:txBody>
+          <a:bodyPr wrap="square" lIns="0" tIns="0" rIns="0" bIns="0" rtlCol="0" anchor="ctr"/>
+          <a:lstStyle/>
+          <a:p>
+            <a:pPr indent="0" marL="0">
+              <a:buNone/>
+            </a:pPr>
+            <a:r>
+              <a:rPr lang="en-US" sz="900" dirty="0">
+                <a:solidFill>
+                  <a:srgbClr val="71717A"/>
+                </a:solidFill>
+                <a:latin typeface="Arial" pitchFamily="34" charset="0"/>
+                <a:ea typeface="Arial" pitchFamily="34" charset="-122"/>
+                <a:cs typeface="Arial" pitchFamily="34" charset="-120"/>
+              </a:rPr>
+              <a:t>Example: a 25.00 USDC commission sold at a 3% discount. Illustration, not outside data.</a:t>
+            </a:r>
+            <a:endParaRPr lang="en-US" sz="900" dirty="0"/>
+          </a:p>
+        </p:txBody>
+      </p:sp>
+    </p:spTree>
+  </p:cSld>
+  <p:clrMapOvr>
+    <a:masterClrMapping/>
+  </p:clrMapOvr>
+</p:sld>
+</file>
+
+<file path=ppt/slides/slide8.xml><?xml version="1.0" encoding="utf-8"?>
+<p:sld xmlns:a="http://schemas.openxmlformats.org/drawingml/2006/main" xmlns:r="http://schemas.openxmlformats.org/officeDocument/2006/relationships" xmlns:p="http://schemas.openxmlformats.org/presentationml/2006/main">
+  <p:cSld name="Slide 8">
+    <p:bg>
+      <p:bgPr>
+        <a:solidFill>
+          <a:srgbClr val="0B0B0E"/>
+        </a:solidFill>
+      </p:bgPr>
+    </p:bg>
+    <p:spTree>
+      <p:nvGrpSpPr>
+        <p:cNvPr id="1" name=""/>
+        <p:cNvGrpSpPr/>
+        <p:nvPr/>
+      </p:nvGrpSpPr>
+      <p:grpSpPr>
+        <a:xfrm>
+          <a:off x="0" y="0"/>
+          <a:ext cx="0" cy="0"/>
+          <a:chOff x="0" y="0"/>
+          <a:chExt cx="0" cy="0"/>
+        </a:xfrm>
+      </p:grpSpPr>
+      <p:sp>
+        <p:nvSpPr>
+          <p:cNvPr id="2" name="Text 0"/>
+          <p:cNvSpPr/>
+          <p:nvPr/>
+        </p:nvSpPr>
+        <p:spPr>
+          <a:xfrm>
+            <a:off x="548640" y="384048"/>
+            <a:ext cx="5486400" cy="256032"/>
+          </a:xfrm>
+          <a:prstGeom prst="rect">
+            <a:avLst/>
+          </a:prstGeom>
+          <a:noFill/>
+          <a:ln/>
+        </p:spPr>
+        <p:txBody>
+          <a:bodyPr wrap="square" lIns="0" tIns="0" rIns="0" bIns="0" rtlCol="0" anchor="ctr"/>
+          <a:lstStyle/>
+          <a:p>
+            <a:pPr indent="0" marL="0">
+              <a:buNone/>
+            </a:pPr>
+            <a:r>
+              <a:rPr lang="en-US" sz="1000" b="1" spc="200" kern="0" dirty="0">
+                <a:solidFill>
+                  <a:srgbClr val="A1A1AA"/>
+                </a:solidFill>
+                <a:latin typeface="Arial" pitchFamily="34" charset="0"/>
+                <a:ea typeface="Arial" pitchFamily="34" charset="-122"/>
+                <a:cs typeface="Arial" pitchFamily="34" charset="-120"/>
+              </a:rPr>
+              <a:t>HOW IT WORKS</a:t>
+            </a:r>
+            <a:endParaRPr lang="en-US" sz="1000" dirty="0"/>
+          </a:p>
+        </p:txBody>
+      </p:sp>
+      <p:sp>
+        <p:nvSpPr>
+          <p:cNvPr id="3" name="Text 1"/>
+          <p:cNvSpPr/>
+          <p:nvPr/>
+        </p:nvSpPr>
+        <p:spPr>
+          <a:xfrm>
+            <a:off x="548640" y="676656"/>
+            <a:ext cx="7498080" cy="914400"/>
+          </a:xfrm>
+          <a:prstGeom prst="rect">
+            <a:avLst/>
+          </a:prstGeom>
+          <a:noFill/>
+          <a:ln/>
+        </p:spPr>
+        <p:txBody>
+          <a:bodyPr wrap="square" lIns="0" tIns="0" rIns="0" bIns="0" rtlCol="0" anchor="t">
+            <a:normAutofit/>
+          </a:bodyPr>
+          <a:lstStyle/>
+          <a:p>
+            <a:pPr indent="0" marL="0">
+              <a:buNone/>
+            </a:pPr>
+            <a:r>
+              <a:rPr lang="en-US" sz="2800" b="1" dirty="0">
+                <a:solidFill>
+                  <a:srgbClr val="F4F4F5"/>
+                </a:solidFill>
+                <a:latin typeface="Arial" pitchFamily="34" charset="0"/>
+                <a:ea typeface="Arial" pitchFamily="34" charset="-122"/>
+                <a:cs typeface="Arial" pitchFamily="34" charset="-120"/>
+              </a:rPr>
+              <a:t>One 9,296-byte program enforces the rules, and 26 tests attack them.</a:t>
+            </a:r>
+            <a:endParaRPr lang="en-US" sz="2800" dirty="0"/>
+          </a:p>
+        </p:txBody>
+      </p:sp>
+      <p:sp>
+        <p:nvSpPr>
+          <p:cNvPr id="4" name="Shape 2"/>
+          <p:cNvSpPr/>
+          <p:nvPr/>
+        </p:nvSpPr>
+        <p:spPr>
+          <a:xfrm>
+            <a:off x="8321040" y="4709160"/>
+            <a:ext cx="548640" cy="274320"/>
+          </a:xfrm>
+          <a:prstGeom prst="roundRect">
+            <a:avLst>
+              <a:gd name="adj" fmla="val 50000"/>
+            </a:avLst>
+          </a:prstGeom>
+          <a:solidFill>
+            <a:srgbClr val="27272A"/>
+          </a:solidFill>
+          <a:ln/>
+        </p:spPr>
+      </p:sp>
+      <p:sp>
+        <p:nvSpPr>
+          <p:cNvPr id="5" name="Text 3"/>
+          <p:cNvSpPr/>
+          <p:nvPr/>
+        </p:nvSpPr>
+        <p:spPr>
+          <a:xfrm>
+            <a:off x="8321040" y="4709160"/>
+            <a:ext cx="548640" cy="274320"/>
+          </a:xfrm>
+          <a:prstGeom prst="rect">
+            <a:avLst/>
+          </a:prstGeom>
+          <a:noFill/>
+          <a:ln/>
+        </p:spPr>
+        <p:txBody>
+          <a:bodyPr wrap="square" lIns="0" tIns="0" rIns="0" bIns="0" rtlCol="0" anchor="ctr"/>
+          <a:lstStyle/>
+          <a:p>
+            <a:pPr algn="ctr" indent="0" marL="0">
+              <a:buNone/>
+            </a:pPr>
+            <a:r>
+              <a:rPr lang="en-US" sz="1000" b="1" dirty="0">
+                <a:solidFill>
+                  <a:srgbClr val="A1A1AA"/>
+                </a:solidFill>
+                <a:latin typeface="Consolas" pitchFamily="34" charset="0"/>
+                <a:ea typeface="Consolas" pitchFamily="34" charset="-122"/>
+                <a:cs typeface="Consolas" pitchFamily="34" charset="-120"/>
+              </a:rPr>
+              <a:t>08</a:t>
+            </a:r>
+            <a:endParaRPr lang="en-US" sz="1000" dirty="0"/>
+          </a:p>
+        </p:txBody>
+      </p:sp>
       <p:graphicFrame>
         <p:nvGraphicFramePr>
-          <p:cNvPr id="8" name="Table 0"/>
+          <p:cNvPr id="9" name="Table 0"/>
           <p:cNvGraphicFramePr>
             <a:graphicFrameLocks noGrp="1"/>
           </p:cNvGraphicFramePr>
@@ -7189,9 +8395,9 @@
 </p:sld>
 </file>
 
-<file path=ppt/slides/slide8.xml><?xml version="1.0" encoding="utf-8"?>
+<file path=ppt/slides/slide9.xml><?xml version="1.0" encoding="utf-8"?>
 <p:sld xmlns:a="http://schemas.openxmlformats.org/drawingml/2006/main" xmlns:r="http://schemas.openxmlformats.org/officeDocument/2006/relationships" xmlns:p="http://schemas.openxmlformats.org/presentationml/2006/main">
-  <p:cSld name="Slide 8">
+  <p:cSld name="Slide 9">
     <p:bg>
       <p:bgPr>
         <a:solidFill>
@@ -7348,7 +8554,7 @@
                 <a:ea typeface="Consolas" pitchFamily="34" charset="-122"/>
                 <a:cs typeface="Consolas" pitchFamily="34" charset="-120"/>
               </a:rPr>
-              <a:t>08</a:t>
+              <a:t>09</a:t>
             </a:r>
             <a:endParaRPr lang="en-US" sz="1000" dirty="0"/>
           </a:p>
@@ -7356,7 +8562,7 @@
       </p:sp>
       <p:graphicFrame>
         <p:nvGraphicFramePr>
-          <p:cNvPr id="9" name="Table 0"/>
+          <p:cNvPr id="10" name="Table 0"/>
           <p:cNvGraphicFramePr>
             <a:graphicFrameLocks noGrp="1"/>
           </p:cNvGraphicFramePr>
@@ -8750,794 +9956,6 @@
                 <a:cs typeface="Arial" pitchFamily="34" charset="-120"/>
               </a:rPr>
               <a:t>Source: Colosseum Copilot API and Arena, 2026-09-27 [S7]</a:t>
-            </a:r>
-            <a:endParaRPr lang="en-US" sz="900" dirty="0"/>
-          </a:p>
-        </p:txBody>
-      </p:sp>
-    </p:spTree>
-  </p:cSld>
-  <p:clrMapOvr>
-    <a:masterClrMapping/>
-  </p:clrMapOvr>
-</p:sld>
-</file>
-
-<file path=ppt/slides/slide9.xml><?xml version="1.0" encoding="utf-8"?>
-<p:sld xmlns:a="http://schemas.openxmlformats.org/drawingml/2006/main" xmlns:r="http://schemas.openxmlformats.org/officeDocument/2006/relationships" xmlns:p="http://schemas.openxmlformats.org/presentationml/2006/main">
-  <p:cSld name="Slide 9">
-    <p:bg>
-      <p:bgPr>
-        <a:solidFill>
-          <a:srgbClr val="0B0B0E"/>
-        </a:solidFill>
-      </p:bgPr>
-    </p:bg>
-    <p:spTree>
-      <p:nvGrpSpPr>
-        <p:cNvPr id="1" name=""/>
-        <p:cNvGrpSpPr/>
-        <p:nvPr/>
-      </p:nvGrpSpPr>
-      <p:grpSpPr>
-        <a:xfrm>
-          <a:off x="0" y="0"/>
-          <a:ext cx="0" cy="0"/>
-          <a:chOff x="0" y="0"/>
-          <a:chExt cx="0" cy="0"/>
-        </a:xfrm>
-      </p:grpSpPr>
-      <p:sp>
-        <p:nvSpPr>
-          <p:cNvPr id="2" name="Text 0"/>
-          <p:cNvSpPr/>
-          <p:nvPr/>
-        </p:nvSpPr>
-        <p:spPr>
-          <a:xfrm>
-            <a:off x="548640" y="384048"/>
-            <a:ext cx="5486400" cy="256032"/>
-          </a:xfrm>
-          <a:prstGeom prst="rect">
-            <a:avLst/>
-          </a:prstGeom>
-          <a:noFill/>
-          <a:ln/>
-        </p:spPr>
-        <p:txBody>
-          <a:bodyPr wrap="square" lIns="0" tIns="0" rIns="0" bIns="0" rtlCol="0" anchor="ctr"/>
-          <a:lstStyle/>
-          <a:p>
-            <a:pPr indent="0" marL="0">
-              <a:buNone/>
-            </a:pPr>
-            <a:r>
-              <a:rPr lang="en-US" sz="1000" b="1" spc="200" kern="0" dirty="0">
-                <a:solidFill>
-                  <a:srgbClr val="A1A1AA"/>
-                </a:solidFill>
-                <a:latin typeface="Arial" pitchFamily="34" charset="0"/>
-                <a:ea typeface="Arial" pitchFamily="34" charset="-122"/>
-                <a:cs typeface="Arial" pitchFamily="34" charset="-120"/>
-              </a:rPr>
-              <a:t>MARKET</a:t>
-            </a:r>
-            <a:endParaRPr lang="en-US" sz="1000" dirty="0"/>
-          </a:p>
-        </p:txBody>
-      </p:sp>
-      <p:sp>
-        <p:nvSpPr>
-          <p:cNvPr id="3" name="Text 1"/>
-          <p:cNvSpPr/>
-          <p:nvPr/>
-        </p:nvSpPr>
-        <p:spPr>
-          <a:xfrm>
-            <a:off x="548640" y="676656"/>
-            <a:ext cx="7498080" cy="914400"/>
-          </a:xfrm>
-          <a:prstGeom prst="rect">
-            <a:avLst/>
-          </a:prstGeom>
-          <a:noFill/>
-          <a:ln/>
-        </p:spPr>
-        <p:txBody>
-          <a:bodyPr wrap="square" lIns="0" tIns="0" rIns="0" bIns="0" rtlCol="0" anchor="t">
-            <a:normAutofit/>
-          </a:bodyPr>
-          <a:lstStyle/>
-          <a:p>
-            <a:pPr indent="0" marL="0">
-              <a:buNone/>
-            </a:pPr>
-            <a:r>
-              <a:rPr lang="en-US" sz="2800" b="1" dirty="0">
-                <a:solidFill>
-                  <a:srgbClr val="F4F4F5"/>
-                </a:solidFill>
-                <a:latin typeface="Arial" pitchFamily="34" charset="0"/>
-                <a:ea typeface="Arial" pitchFamily="34" charset="-122"/>
-                <a:cs typeface="Arial" pitchFamily="34" charset="-120"/>
-              </a:rPr>
-              <a:t>US brands will spend $13.81 billion on affiliate marketing in 2026.</a:t>
-            </a:r>
-            <a:endParaRPr lang="en-US" sz="2800" dirty="0"/>
-          </a:p>
-        </p:txBody>
-      </p:sp>
-      <p:sp>
-        <p:nvSpPr>
-          <p:cNvPr id="4" name="Shape 2"/>
-          <p:cNvSpPr/>
-          <p:nvPr/>
-        </p:nvSpPr>
-        <p:spPr>
-          <a:xfrm>
-            <a:off x="8321040" y="4709160"/>
-            <a:ext cx="548640" cy="274320"/>
-          </a:xfrm>
-          <a:prstGeom prst="roundRect">
-            <a:avLst>
-              <a:gd name="adj" fmla="val 50000"/>
-            </a:avLst>
-          </a:prstGeom>
-          <a:solidFill>
-            <a:srgbClr val="27272A"/>
-          </a:solidFill>
-          <a:ln/>
-        </p:spPr>
-      </p:sp>
-      <p:sp>
-        <p:nvSpPr>
-          <p:cNvPr id="5" name="Text 3"/>
-          <p:cNvSpPr/>
-          <p:nvPr/>
-        </p:nvSpPr>
-        <p:spPr>
-          <a:xfrm>
-            <a:off x="8321040" y="4709160"/>
-            <a:ext cx="548640" cy="274320"/>
-          </a:xfrm>
-          <a:prstGeom prst="rect">
-            <a:avLst/>
-          </a:prstGeom>
-          <a:noFill/>
-          <a:ln/>
-        </p:spPr>
-        <p:txBody>
-          <a:bodyPr wrap="square" lIns="0" tIns="0" rIns="0" bIns="0" rtlCol="0" anchor="ctr"/>
-          <a:lstStyle/>
-          <a:p>
-            <a:pPr algn="ctr" indent="0" marL="0">
-              <a:buNone/>
-            </a:pPr>
-            <a:r>
-              <a:rPr lang="en-US" sz="1000" b="1" dirty="0">
-                <a:solidFill>
-                  <a:srgbClr val="A1A1AA"/>
-                </a:solidFill>
-                <a:latin typeface="Consolas" pitchFamily="34" charset="0"/>
-                <a:ea typeface="Consolas" pitchFamily="34" charset="-122"/>
-                <a:cs typeface="Consolas" pitchFamily="34" charset="-120"/>
-              </a:rPr>
-              <a:t>09</a:t>
-            </a:r>
-            <a:endParaRPr lang="en-US" sz="1000" dirty="0"/>
-          </a:p>
-        </p:txBody>
-      </p:sp>
-      <p:sp>
-        <p:nvSpPr>
-          <p:cNvPr id="6" name="Text 4"/>
-          <p:cNvSpPr/>
-          <p:nvPr/>
-        </p:nvSpPr>
-        <p:spPr>
-          <a:xfrm>
-            <a:off x="548640" y="1691640"/>
-            <a:ext cx="5486400" cy="1371600"/>
-          </a:xfrm>
-          <a:prstGeom prst="rect">
-            <a:avLst/>
-          </a:prstGeom>
-          <a:noFill/>
-          <a:ln/>
-        </p:spPr>
-        <p:txBody>
-          <a:bodyPr wrap="square" lIns="0" tIns="0" rIns="0" bIns="0" rtlCol="0" anchor="ctr"/>
-          <a:lstStyle/>
-          <a:p>
-            <a:pPr indent="0" marL="0">
-              <a:buNone/>
-            </a:pPr>
-            <a:r>
-              <a:rPr lang="en-US" sz="8400" b="1" dirty="0">
-                <a:solidFill>
-                  <a:srgbClr val="3DDC97"/>
-                </a:solidFill>
-                <a:latin typeface="Arial" pitchFamily="34" charset="0"/>
-                <a:ea typeface="Arial" pitchFamily="34" charset="-122"/>
-                <a:cs typeface="Arial" pitchFamily="34" charset="-120"/>
-              </a:rPr>
-              <a:t>$13.81B</a:t>
-            </a:r>
-            <a:endParaRPr lang="en-US" sz="8400" dirty="0"/>
-          </a:p>
-        </p:txBody>
-      </p:sp>
-      <p:sp>
-        <p:nvSpPr>
-          <p:cNvPr id="7" name="Shape 5"/>
-          <p:cNvSpPr/>
-          <p:nvPr/>
-        </p:nvSpPr>
-        <p:spPr>
-          <a:xfrm>
-            <a:off x="548640" y="3337560"/>
-            <a:ext cx="1645920" cy="868680"/>
-          </a:xfrm>
-          <a:prstGeom prst="roundRect">
-            <a:avLst>
-              <a:gd name="adj" fmla="val 10526"/>
-            </a:avLst>
-          </a:prstGeom>
-          <a:solidFill>
-            <a:srgbClr val="141417"/>
-          </a:solidFill>
-          <a:ln w="12700">
-            <a:solidFill>
-              <a:srgbClr val="27272A"/>
-            </a:solidFill>
-            <a:prstDash val="solid"/>
-          </a:ln>
-        </p:spPr>
-      </p:sp>
-      <p:sp>
-        <p:nvSpPr>
-          <p:cNvPr id="8" name="Text 6"/>
-          <p:cNvSpPr/>
-          <p:nvPr/>
-        </p:nvSpPr>
-        <p:spPr>
-          <a:xfrm>
-            <a:off x="685800" y="3410712"/>
-            <a:ext cx="1417320" cy="411480"/>
-          </a:xfrm>
-          <a:prstGeom prst="rect">
-            <a:avLst/>
-          </a:prstGeom>
-          <a:noFill/>
-          <a:ln/>
-        </p:spPr>
-        <p:txBody>
-          <a:bodyPr wrap="square" lIns="0" tIns="0" rIns="0" bIns="0" rtlCol="0" anchor="ctr"/>
-          <a:lstStyle/>
-          <a:p>
-            <a:pPr indent="0" marL="0">
-              <a:buNone/>
-            </a:pPr>
-            <a:r>
-              <a:rPr lang="en-US" sz="2000" b="1" dirty="0">
-                <a:solidFill>
-                  <a:srgbClr val="F4F4F5"/>
-                </a:solidFill>
-                <a:latin typeface="Arial" pitchFamily="34" charset="0"/>
-                <a:ea typeface="Arial" pitchFamily="34" charset="-122"/>
-                <a:cs typeface="Arial" pitchFamily="34" charset="-120"/>
-              </a:rPr>
-              <a:t>$13.81B</a:t>
-            </a:r>
-            <a:endParaRPr lang="en-US" sz="2000" dirty="0"/>
-          </a:p>
-        </p:txBody>
-      </p:sp>
-      <p:sp>
-        <p:nvSpPr>
-          <p:cNvPr id="9" name="Text 7"/>
-          <p:cNvSpPr/>
-          <p:nvPr/>
-        </p:nvSpPr>
-        <p:spPr>
-          <a:xfrm>
-            <a:off x="685800" y="3822192"/>
-            <a:ext cx="1463040" cy="274320"/>
-          </a:xfrm>
-          <a:prstGeom prst="rect">
-            <a:avLst/>
-          </a:prstGeom>
-          <a:noFill/>
-          <a:ln/>
-        </p:spPr>
-        <p:txBody>
-          <a:bodyPr wrap="square" lIns="0" tIns="0" rIns="0" bIns="0" rtlCol="0" anchor="ctr"/>
-          <a:lstStyle/>
-          <a:p>
-            <a:pPr indent="0" marL="0">
-              <a:buNone/>
-            </a:pPr>
-            <a:r>
-              <a:rPr lang="en-US" sz="1000" dirty="0">
-                <a:solidFill>
-                  <a:srgbClr val="A1A1AA"/>
-                </a:solidFill>
-                <a:latin typeface="Arial" pitchFamily="34" charset="0"/>
-                <a:ea typeface="Arial" pitchFamily="34" charset="-122"/>
-                <a:cs typeface="Arial" pitchFamily="34" charset="-120"/>
-              </a:rPr>
-              <a:t>US affiliate spend</a:t>
-            </a:r>
-            <a:endParaRPr lang="en-US" sz="1000" dirty="0"/>
-          </a:p>
-        </p:txBody>
-      </p:sp>
-      <p:sp>
-        <p:nvSpPr>
-          <p:cNvPr id="10" name="Text 8"/>
-          <p:cNvSpPr/>
-          <p:nvPr/>
-        </p:nvSpPr>
-        <p:spPr>
-          <a:xfrm>
-            <a:off x="2194560" y="3566160"/>
-            <a:ext cx="365760" cy="411480"/>
-          </a:xfrm>
-          <a:prstGeom prst="rect">
-            <a:avLst/>
-          </a:prstGeom>
-          <a:noFill/>
-          <a:ln/>
-        </p:spPr>
-        <p:txBody>
-          <a:bodyPr wrap="square" lIns="0" tIns="0" rIns="0" bIns="0" rtlCol="0" anchor="ctr"/>
-          <a:lstStyle/>
-          <a:p>
-            <a:pPr algn="ctr" indent="0" marL="0">
-              <a:buNone/>
-            </a:pPr>
-            <a:r>
-              <a:rPr lang="en-US" sz="1800" dirty="0">
-                <a:solidFill>
-                  <a:srgbClr val="A1A1AA"/>
-                </a:solidFill>
-                <a:latin typeface="Arial" pitchFamily="34" charset="0"/>
-                <a:ea typeface="Arial" pitchFamily="34" charset="-122"/>
-                <a:cs typeface="Arial" pitchFamily="34" charset="-120"/>
-              </a:rPr>
-              <a:t>×</a:t>
-            </a:r>
-            <a:endParaRPr lang="en-US" sz="1800" dirty="0"/>
-          </a:p>
-        </p:txBody>
-      </p:sp>
-      <p:sp>
-        <p:nvSpPr>
-          <p:cNvPr id="11" name="Shape 9"/>
-          <p:cNvSpPr/>
-          <p:nvPr/>
-        </p:nvSpPr>
-        <p:spPr>
-          <a:xfrm>
-            <a:off x="2560320" y="3337560"/>
-            <a:ext cx="1645920" cy="868680"/>
-          </a:xfrm>
-          <a:prstGeom prst="roundRect">
-            <a:avLst>
-              <a:gd name="adj" fmla="val 10526"/>
-            </a:avLst>
-          </a:prstGeom>
-          <a:solidFill>
-            <a:srgbClr val="141417"/>
-          </a:solidFill>
-          <a:ln w="12700">
-            <a:solidFill>
-              <a:srgbClr val="27272A"/>
-            </a:solidFill>
-            <a:prstDash val="solid"/>
-          </a:ln>
-        </p:spPr>
-      </p:sp>
-      <p:sp>
-        <p:nvSpPr>
-          <p:cNvPr id="12" name="Text 10"/>
-          <p:cNvSpPr/>
-          <p:nvPr/>
-        </p:nvSpPr>
-        <p:spPr>
-          <a:xfrm>
-            <a:off x="2697480" y="3410712"/>
-            <a:ext cx="1417320" cy="411480"/>
-          </a:xfrm>
-          <a:prstGeom prst="rect">
-            <a:avLst/>
-          </a:prstGeom>
-          <a:noFill/>
-          <a:ln/>
-        </p:spPr>
-        <p:txBody>
-          <a:bodyPr wrap="square" lIns="0" tIns="0" rIns="0" bIns="0" rtlCol="0" anchor="ctr"/>
-          <a:lstStyle/>
-          <a:p>
-            <a:pPr indent="0" marL="0">
-              <a:buNone/>
-            </a:pPr>
-            <a:r>
-              <a:rPr lang="en-US" sz="2000" b="1" dirty="0">
-                <a:solidFill>
-                  <a:srgbClr val="F4F4F5"/>
-                </a:solidFill>
-                <a:latin typeface="Arial" pitchFamily="34" charset="0"/>
-                <a:ea typeface="Arial" pitchFamily="34" charset="-122"/>
-                <a:cs typeface="Arial" pitchFamily="34" charset="-120"/>
-              </a:rPr>
-              <a:t>1%</a:t>
-            </a:r>
-            <a:endParaRPr lang="en-US" sz="2000" dirty="0"/>
-          </a:p>
-        </p:txBody>
-      </p:sp>
-      <p:sp>
-        <p:nvSpPr>
-          <p:cNvPr id="13" name="Text 11"/>
-          <p:cNvSpPr/>
-          <p:nvPr/>
-        </p:nvSpPr>
-        <p:spPr>
-          <a:xfrm>
-            <a:off x="2697480" y="3822192"/>
-            <a:ext cx="1463040" cy="274320"/>
-          </a:xfrm>
-          <a:prstGeom prst="rect">
-            <a:avLst/>
-          </a:prstGeom>
-          <a:noFill/>
-          <a:ln/>
-        </p:spPr>
-        <p:txBody>
-          <a:bodyPr wrap="square" lIns="0" tIns="0" rIns="0" bIns="0" rtlCol="0" anchor="ctr"/>
-          <a:lstStyle/>
-          <a:p>
-            <a:pPr indent="0" marL="0">
-              <a:buNone/>
-            </a:pPr>
-            <a:r>
-              <a:rPr lang="en-US" sz="1000" dirty="0">
-                <a:solidFill>
-                  <a:srgbClr val="A1A1AA"/>
-                </a:solidFill>
-                <a:latin typeface="Arial" pitchFamily="34" charset="0"/>
-                <a:ea typeface="Arial" pitchFamily="34" charset="-122"/>
-                <a:cs typeface="Arial" pitchFamily="34" charset="-120"/>
-              </a:rPr>
-              <a:t>settled on Commish</a:t>
-            </a:r>
-            <a:endParaRPr lang="en-US" sz="1000" dirty="0"/>
-          </a:p>
-        </p:txBody>
-      </p:sp>
-      <p:sp>
-        <p:nvSpPr>
-          <p:cNvPr id="14" name="Text 12"/>
-          <p:cNvSpPr/>
-          <p:nvPr/>
-        </p:nvSpPr>
-        <p:spPr>
-          <a:xfrm>
-            <a:off x="4206240" y="3566160"/>
-            <a:ext cx="365760" cy="411480"/>
-          </a:xfrm>
-          <a:prstGeom prst="rect">
-            <a:avLst/>
-          </a:prstGeom>
-          <a:noFill/>
-          <a:ln/>
-        </p:spPr>
-        <p:txBody>
-          <a:bodyPr wrap="square" lIns="0" tIns="0" rIns="0" bIns="0" rtlCol="0" anchor="ctr"/>
-          <a:lstStyle/>
-          <a:p>
-            <a:pPr algn="ctr" indent="0" marL="0">
-              <a:buNone/>
-            </a:pPr>
-            <a:r>
-              <a:rPr lang="en-US" sz="1800" dirty="0">
-                <a:solidFill>
-                  <a:srgbClr val="A1A1AA"/>
-                </a:solidFill>
-                <a:latin typeface="Arial" pitchFamily="34" charset="0"/>
-                <a:ea typeface="Arial" pitchFamily="34" charset="-122"/>
-                <a:cs typeface="Arial" pitchFamily="34" charset="-120"/>
-              </a:rPr>
-              <a:t>×</a:t>
-            </a:r>
-            <a:endParaRPr lang="en-US" sz="1800" dirty="0"/>
-          </a:p>
-        </p:txBody>
-      </p:sp>
-      <p:sp>
-        <p:nvSpPr>
-          <p:cNvPr id="15" name="Shape 13"/>
-          <p:cNvSpPr/>
-          <p:nvPr/>
-        </p:nvSpPr>
-        <p:spPr>
-          <a:xfrm>
-            <a:off x="4572000" y="3337560"/>
-            <a:ext cx="1645920" cy="868680"/>
-          </a:xfrm>
-          <a:prstGeom prst="roundRect">
-            <a:avLst>
-              <a:gd name="adj" fmla="val 10526"/>
-            </a:avLst>
-          </a:prstGeom>
-          <a:solidFill>
-            <a:srgbClr val="141417"/>
-          </a:solidFill>
-          <a:ln w="12700">
-            <a:solidFill>
-              <a:srgbClr val="27272A"/>
-            </a:solidFill>
-            <a:prstDash val="solid"/>
-          </a:ln>
-        </p:spPr>
-      </p:sp>
-      <p:sp>
-        <p:nvSpPr>
-          <p:cNvPr id="16" name="Text 14"/>
-          <p:cNvSpPr/>
-          <p:nvPr/>
-        </p:nvSpPr>
-        <p:spPr>
-          <a:xfrm>
-            <a:off x="4709160" y="3410712"/>
-            <a:ext cx="1417320" cy="411480"/>
-          </a:xfrm>
-          <a:prstGeom prst="rect">
-            <a:avLst/>
-          </a:prstGeom>
-          <a:noFill/>
-          <a:ln/>
-        </p:spPr>
-        <p:txBody>
-          <a:bodyPr wrap="square" lIns="0" tIns="0" rIns="0" bIns="0" rtlCol="0" anchor="ctr"/>
-          <a:lstStyle/>
-          <a:p>
-            <a:pPr indent="0" marL="0">
-              <a:buNone/>
-            </a:pPr>
-            <a:r>
-              <a:rPr lang="en-US" sz="2000" b="1" dirty="0">
-                <a:solidFill>
-                  <a:srgbClr val="F4F4F5"/>
-                </a:solidFill>
-                <a:latin typeface="Arial" pitchFamily="34" charset="0"/>
-                <a:ea typeface="Arial" pitchFamily="34" charset="-122"/>
-                <a:cs typeface="Arial" pitchFamily="34" charset="-120"/>
-              </a:rPr>
-              <a:t>1%</a:t>
-            </a:r>
-            <a:endParaRPr lang="en-US" sz="2000" dirty="0"/>
-          </a:p>
-        </p:txBody>
-      </p:sp>
-      <p:sp>
-        <p:nvSpPr>
-          <p:cNvPr id="17" name="Text 15"/>
-          <p:cNvSpPr/>
-          <p:nvPr/>
-        </p:nvSpPr>
-        <p:spPr>
-          <a:xfrm>
-            <a:off x="4709160" y="3822192"/>
-            <a:ext cx="1463040" cy="274320"/>
-          </a:xfrm>
-          <a:prstGeom prst="rect">
-            <a:avLst/>
-          </a:prstGeom>
-          <a:noFill/>
-          <a:ln/>
-        </p:spPr>
-        <p:txBody>
-          <a:bodyPr wrap="square" lIns="0" tIns="0" rIns="0" bIns="0" rtlCol="0" anchor="ctr"/>
-          <a:lstStyle/>
-          <a:p>
-            <a:pPr indent="0" marL="0">
-              <a:buNone/>
-            </a:pPr>
-            <a:r>
-              <a:rPr lang="en-US" sz="1000" dirty="0">
-                <a:solidFill>
-                  <a:srgbClr val="A1A1AA"/>
-                </a:solidFill>
-                <a:latin typeface="Arial" pitchFamily="34" charset="0"/>
-                <a:ea typeface="Arial" pitchFamily="34" charset="-122"/>
-                <a:cs typeface="Arial" pitchFamily="34" charset="-120"/>
-              </a:rPr>
-              <a:t>fee on each payout</a:t>
-            </a:r>
-            <a:endParaRPr lang="en-US" sz="1000" dirty="0"/>
-          </a:p>
-        </p:txBody>
-      </p:sp>
-      <p:sp>
-        <p:nvSpPr>
-          <p:cNvPr id="18" name="Text 16"/>
-          <p:cNvSpPr/>
-          <p:nvPr/>
-        </p:nvSpPr>
-        <p:spPr>
-          <a:xfrm>
-            <a:off x="6217920" y="3566160"/>
-            <a:ext cx="365760" cy="411480"/>
-          </a:xfrm>
-          <a:prstGeom prst="rect">
-            <a:avLst/>
-          </a:prstGeom>
-          <a:noFill/>
-          <a:ln/>
-        </p:spPr>
-        <p:txBody>
-          <a:bodyPr wrap="square" lIns="0" tIns="0" rIns="0" bIns="0" rtlCol="0" anchor="ctr"/>
-          <a:lstStyle/>
-          <a:p>
-            <a:pPr algn="ctr" indent="0" marL="0">
-              <a:buNone/>
-            </a:pPr>
-            <a:r>
-              <a:rPr lang="en-US" sz="1800" dirty="0">
-                <a:solidFill>
-                  <a:srgbClr val="A1A1AA"/>
-                </a:solidFill>
-                <a:latin typeface="Arial" pitchFamily="34" charset="0"/>
-                <a:ea typeface="Arial" pitchFamily="34" charset="-122"/>
-                <a:cs typeface="Arial" pitchFamily="34" charset="-120"/>
-              </a:rPr>
-              <a:t>=</a:t>
-            </a:r>
-            <a:endParaRPr lang="en-US" sz="1800" dirty="0"/>
-          </a:p>
-        </p:txBody>
-      </p:sp>
-      <p:sp>
-        <p:nvSpPr>
-          <p:cNvPr id="19" name="Shape 17"/>
-          <p:cNvSpPr/>
-          <p:nvPr/>
-        </p:nvSpPr>
-        <p:spPr>
-          <a:xfrm>
-            <a:off x="6583680" y="3337560"/>
-            <a:ext cx="1645920" cy="868680"/>
-          </a:xfrm>
-          <a:prstGeom prst="roundRect">
-            <a:avLst>
-              <a:gd name="adj" fmla="val 10526"/>
-            </a:avLst>
-          </a:prstGeom>
-          <a:solidFill>
-            <a:srgbClr val="141417"/>
-          </a:solidFill>
-          <a:ln w="19050">
-            <a:solidFill>
-              <a:srgbClr val="3DDC97"/>
-            </a:solidFill>
-            <a:prstDash val="solid"/>
-          </a:ln>
-        </p:spPr>
-      </p:sp>
-      <p:sp>
-        <p:nvSpPr>
-          <p:cNvPr id="20" name="Text 18"/>
-          <p:cNvSpPr/>
-          <p:nvPr/>
-        </p:nvSpPr>
-        <p:spPr>
-          <a:xfrm>
-            <a:off x="6720840" y="3410712"/>
-            <a:ext cx="1417320" cy="411480"/>
-          </a:xfrm>
-          <a:prstGeom prst="rect">
-            <a:avLst/>
-          </a:prstGeom>
-          <a:noFill/>
-          <a:ln/>
-        </p:spPr>
-        <p:txBody>
-          <a:bodyPr wrap="square" lIns="0" tIns="0" rIns="0" bIns="0" rtlCol="0" anchor="ctr"/>
-          <a:lstStyle/>
-          <a:p>
-            <a:pPr indent="0" marL="0">
-              <a:buNone/>
-            </a:pPr>
-            <a:r>
-              <a:rPr lang="en-US" sz="2000" b="1" dirty="0">
-                <a:solidFill>
-                  <a:srgbClr val="3DDC97"/>
-                </a:solidFill>
-                <a:latin typeface="Arial" pitchFamily="34" charset="0"/>
-                <a:ea typeface="Arial" pitchFamily="34" charset="-122"/>
-                <a:cs typeface="Arial" pitchFamily="34" charset="-120"/>
-              </a:rPr>
-              <a:t>$1.38M</a:t>
-            </a:r>
-            <a:endParaRPr lang="en-US" sz="2000" dirty="0"/>
-          </a:p>
-        </p:txBody>
-      </p:sp>
-      <p:sp>
-        <p:nvSpPr>
-          <p:cNvPr id="21" name="Text 19"/>
-          <p:cNvSpPr/>
-          <p:nvPr/>
-        </p:nvSpPr>
-        <p:spPr>
-          <a:xfrm>
-            <a:off x="6720840" y="3822192"/>
-            <a:ext cx="1463040" cy="274320"/>
-          </a:xfrm>
-          <a:prstGeom prst="rect">
-            <a:avLst/>
-          </a:prstGeom>
-          <a:noFill/>
-          <a:ln/>
-        </p:spPr>
-        <p:txBody>
-          <a:bodyPr wrap="square" lIns="0" tIns="0" rIns="0" bIns="0" rtlCol="0" anchor="ctr"/>
-          <a:lstStyle/>
-          <a:p>
-            <a:pPr indent="0" marL="0">
-              <a:buNone/>
-            </a:pPr>
-            <a:r>
-              <a:rPr lang="en-US" sz="1000" dirty="0">
-                <a:solidFill>
-                  <a:srgbClr val="A1A1AA"/>
-                </a:solidFill>
-                <a:latin typeface="Arial" pitchFamily="34" charset="0"/>
-                <a:ea typeface="Arial" pitchFamily="34" charset="-122"/>
-                <a:cs typeface="Arial" pitchFamily="34" charset="-120"/>
-              </a:rPr>
-              <a:t>a year</a:t>
-            </a:r>
-            <a:endParaRPr lang="en-US" sz="1000" dirty="0"/>
-          </a:p>
-        </p:txBody>
-      </p:sp>
-      <p:sp>
-        <p:nvSpPr>
-          <p:cNvPr id="22" name="Text 20"/>
-          <p:cNvSpPr/>
-          <p:nvPr/>
-        </p:nvSpPr>
-        <p:spPr>
-          <a:xfrm>
-            <a:off x="548640" y="4681728"/>
-            <a:ext cx="7589520" cy="274320"/>
-          </a:xfrm>
-          <a:prstGeom prst="rect">
-            <a:avLst/>
-          </a:prstGeom>
-          <a:noFill/>
-          <a:ln/>
-        </p:spPr>
-        <p:txBody>
-          <a:bodyPr wrap="square" lIns="0" tIns="0" rIns="0" bIns="0" rtlCol="0" anchor="ctr"/>
-          <a:lstStyle/>
-          <a:p>
-            <a:pPr indent="0" marL="0">
-              <a:buNone/>
-            </a:pPr>
-            <a:r>
-              <a:rPr lang="en-US" sz="900" dirty="0">
-                <a:solidFill>
-                  <a:srgbClr val="71717A"/>
-                </a:solidFill>
-                <a:latin typeface="Arial" pitchFamily="34" charset="0"/>
-                <a:ea typeface="Arial" pitchFamily="34" charset="-122"/>
-                <a:cs typeface="Arial" pitchFamily="34" charset="-120"/>
-              </a:rPr>
-              <a:t>Source: eMarketer forecast via Post Affiliate Pro [S3]. Share and fee are team plan, not outside data.</a:t>
             </a:r>
             <a:endParaRPr lang="en-US" sz="900" dirty="0"/>
           </a:p>

</xml_diff>